<commit_message>
Incremental Build at 2026-10-16 22:37:00
</commit_message>
<xml_diff>
--- a/Lectures/Slides/L3.pptx
+++ b/Lectures/Slides/L3.pptx
@@ -68,7 +68,7 @@
         <a:solidFill>
           <a:srgbClr val="000000"/>
         </a:solidFill>
-        <a:latin typeface="Arial"/>
+        <a:latin typeface="Atkinson Hyperlegible Next"/>
         <a:ea typeface="Arial"/>
         <a:cs typeface="Arial"/>
         <a:sym typeface="Arial"/>
@@ -92,7 +92,7 @@
         <a:solidFill>
           <a:srgbClr val="000000"/>
         </a:solidFill>
-        <a:latin typeface="Arial"/>
+        <a:latin typeface="Atkinson Hyperlegible Next"/>
         <a:ea typeface="Arial"/>
         <a:cs typeface="Arial"/>
         <a:sym typeface="Arial"/>
@@ -116,7 +116,7 @@
         <a:solidFill>
           <a:srgbClr val="000000"/>
         </a:solidFill>
-        <a:latin typeface="Arial"/>
+        <a:latin typeface="Atkinson Hyperlegible Next"/>
         <a:ea typeface="Arial"/>
         <a:cs typeface="Arial"/>
         <a:sym typeface="Arial"/>
@@ -140,7 +140,7 @@
         <a:solidFill>
           <a:srgbClr val="000000"/>
         </a:solidFill>
-        <a:latin typeface="Arial"/>
+        <a:latin typeface="Atkinson Hyperlegible Next"/>
         <a:ea typeface="Arial"/>
         <a:cs typeface="Arial"/>
         <a:sym typeface="Arial"/>
@@ -164,7 +164,7 @@
         <a:solidFill>
           <a:srgbClr val="000000"/>
         </a:solidFill>
-        <a:latin typeface="Arial"/>
+        <a:latin typeface="Atkinson Hyperlegible Next"/>
         <a:ea typeface="Arial"/>
         <a:cs typeface="Arial"/>
         <a:sym typeface="Arial"/>
@@ -188,7 +188,7 @@
         <a:solidFill>
           <a:srgbClr val="000000"/>
         </a:solidFill>
-        <a:latin typeface="Arial"/>
+        <a:latin typeface="Atkinson Hyperlegible Next"/>
         <a:ea typeface="Arial"/>
         <a:cs typeface="Arial"/>
         <a:sym typeface="Arial"/>
@@ -212,7 +212,7 @@
         <a:solidFill>
           <a:srgbClr val="000000"/>
         </a:solidFill>
-        <a:latin typeface="Arial"/>
+        <a:latin typeface="Atkinson Hyperlegible Next"/>
         <a:ea typeface="Arial"/>
         <a:cs typeface="Arial"/>
         <a:sym typeface="Arial"/>
@@ -236,7 +236,7 @@
         <a:solidFill>
           <a:srgbClr val="000000"/>
         </a:solidFill>
-        <a:latin typeface="Arial"/>
+        <a:latin typeface="Atkinson Hyperlegible Next"/>
         <a:ea typeface="Arial"/>
         <a:cs typeface="Arial"/>
         <a:sym typeface="Arial"/>
@@ -260,7 +260,7 @@
         <a:solidFill>
           <a:srgbClr val="000000"/>
         </a:solidFill>
-        <a:latin typeface="Arial"/>
+        <a:latin typeface="Atkinson Hyperlegible Next"/>
         <a:ea typeface="Arial"/>
         <a:cs typeface="Arial"/>
         <a:sym typeface="Arial"/>
@@ -351,7 +351,7 @@
                 <a:solidFill>
                   <a:schemeClr val="dk1"/>
                 </a:solidFill>
-                <a:latin typeface="Calibri"/>
+                <a:latin typeface="Atkinson Hyperlegible Next"/>
                 <a:ea typeface="Calibri"/>
                 <a:cs typeface="Calibri"/>
                 <a:sym typeface="Calibri"/>
@@ -377,7 +377,7 @@
                 <a:solidFill>
                   <a:schemeClr val="dk1"/>
                 </a:solidFill>
-                <a:latin typeface="Calibri"/>
+                <a:latin typeface="Atkinson Hyperlegible Next"/>
                 <a:ea typeface="Calibri"/>
                 <a:cs typeface="Calibri"/>
                 <a:sym typeface="Calibri"/>
@@ -403,7 +403,7 @@
                 <a:solidFill>
                   <a:schemeClr val="dk1"/>
                 </a:solidFill>
-                <a:latin typeface="Calibri"/>
+                <a:latin typeface="Atkinson Hyperlegible Next"/>
                 <a:ea typeface="Calibri"/>
                 <a:cs typeface="Calibri"/>
                 <a:sym typeface="Calibri"/>
@@ -429,7 +429,7 @@
                 <a:solidFill>
                   <a:schemeClr val="dk1"/>
                 </a:solidFill>
-                <a:latin typeface="Calibri"/>
+                <a:latin typeface="Atkinson Hyperlegible Next"/>
                 <a:ea typeface="Calibri"/>
                 <a:cs typeface="Calibri"/>
                 <a:sym typeface="Calibri"/>
@@ -455,7 +455,7 @@
                 <a:solidFill>
                   <a:schemeClr val="dk1"/>
                 </a:solidFill>
-                <a:latin typeface="Calibri"/>
+                <a:latin typeface="Atkinson Hyperlegible Next"/>
                 <a:ea typeface="Calibri"/>
                 <a:cs typeface="Calibri"/>
                 <a:sym typeface="Calibri"/>
@@ -481,7 +481,7 @@
                 <a:solidFill>
                   <a:schemeClr val="dk1"/>
                 </a:solidFill>
-                <a:latin typeface="Calibri"/>
+                <a:latin typeface="Atkinson Hyperlegible Next"/>
                 <a:ea typeface="Calibri"/>
                 <a:cs typeface="Calibri"/>
                 <a:sym typeface="Calibri"/>
@@ -507,7 +507,7 @@
                 <a:solidFill>
                   <a:schemeClr val="dk1"/>
                 </a:solidFill>
-                <a:latin typeface="Calibri"/>
+                <a:latin typeface="Atkinson Hyperlegible Next"/>
                 <a:ea typeface="Calibri"/>
                 <a:cs typeface="Calibri"/>
                 <a:sym typeface="Calibri"/>
@@ -533,7 +533,7 @@
                 <a:solidFill>
                   <a:schemeClr val="dk1"/>
                 </a:solidFill>
-                <a:latin typeface="Calibri"/>
+                <a:latin typeface="Atkinson Hyperlegible Next"/>
                 <a:ea typeface="Calibri"/>
                 <a:cs typeface="Calibri"/>
                 <a:sym typeface="Calibri"/>
@@ -559,7 +559,7 @@
                 <a:solidFill>
                   <a:schemeClr val="dk1"/>
                 </a:solidFill>
-                <a:latin typeface="Calibri"/>
+                <a:latin typeface="Atkinson Hyperlegible Next"/>
                 <a:ea typeface="Calibri"/>
                 <a:cs typeface="Calibri"/>
                 <a:sym typeface="Calibri"/>
@@ -619,7 +619,7 @@
                 <a:solidFill>
                   <a:schemeClr val="dk1"/>
                 </a:solidFill>
-                <a:latin typeface="Calibri"/>
+                <a:latin typeface="Atkinson Hyperlegible Next"/>
                 <a:ea typeface="Calibri"/>
                 <a:cs typeface="Calibri"/>
                 <a:sym typeface="Calibri"/>
@@ -645,7 +645,7 @@
                 <a:solidFill>
                   <a:schemeClr val="dk1"/>
                 </a:solidFill>
-                <a:latin typeface="Calibri"/>
+                <a:latin typeface="Atkinson Hyperlegible Next"/>
                 <a:ea typeface="Calibri"/>
                 <a:cs typeface="Calibri"/>
                 <a:sym typeface="Calibri"/>
@@ -671,7 +671,7 @@
                 <a:solidFill>
                   <a:schemeClr val="dk1"/>
                 </a:solidFill>
-                <a:latin typeface="Calibri"/>
+                <a:latin typeface="Atkinson Hyperlegible Next"/>
                 <a:ea typeface="Calibri"/>
                 <a:cs typeface="Calibri"/>
                 <a:sym typeface="Calibri"/>
@@ -697,7 +697,7 @@
                 <a:solidFill>
                   <a:schemeClr val="dk1"/>
                 </a:solidFill>
-                <a:latin typeface="Calibri"/>
+                <a:latin typeface="Atkinson Hyperlegible Next"/>
                 <a:ea typeface="Calibri"/>
                 <a:cs typeface="Calibri"/>
                 <a:sym typeface="Calibri"/>
@@ -723,7 +723,7 @@
                 <a:solidFill>
                   <a:schemeClr val="dk1"/>
                 </a:solidFill>
-                <a:latin typeface="Calibri"/>
+                <a:latin typeface="Atkinson Hyperlegible Next"/>
                 <a:ea typeface="Calibri"/>
                 <a:cs typeface="Calibri"/>
                 <a:sym typeface="Calibri"/>
@@ -749,7 +749,7 @@
                 <a:solidFill>
                   <a:schemeClr val="dk1"/>
                 </a:solidFill>
-                <a:latin typeface="Calibri"/>
+                <a:latin typeface="Atkinson Hyperlegible Next"/>
                 <a:ea typeface="Calibri"/>
                 <a:cs typeface="Calibri"/>
                 <a:sym typeface="Calibri"/>
@@ -775,7 +775,7 @@
                 <a:solidFill>
                   <a:schemeClr val="dk1"/>
                 </a:solidFill>
-                <a:latin typeface="Calibri"/>
+                <a:latin typeface="Atkinson Hyperlegible Next"/>
                 <a:ea typeface="Calibri"/>
                 <a:cs typeface="Calibri"/>
                 <a:sym typeface="Calibri"/>
@@ -801,7 +801,7 @@
                 <a:solidFill>
                   <a:schemeClr val="dk1"/>
                 </a:solidFill>
-                <a:latin typeface="Calibri"/>
+                <a:latin typeface="Atkinson Hyperlegible Next"/>
                 <a:ea typeface="Calibri"/>
                 <a:cs typeface="Calibri"/>
                 <a:sym typeface="Calibri"/>
@@ -827,7 +827,7 @@
                 <a:solidFill>
                   <a:schemeClr val="dk1"/>
                 </a:solidFill>
-                <a:latin typeface="Calibri"/>
+                <a:latin typeface="Atkinson Hyperlegible Next"/>
                 <a:ea typeface="Calibri"/>
                 <a:cs typeface="Calibri"/>
                 <a:sym typeface="Calibri"/>
@@ -938,7 +938,7 @@
                 <a:solidFill>
                   <a:schemeClr val="dk1"/>
                 </a:solidFill>
-                <a:latin typeface="Calibri"/>
+                <a:latin typeface="Atkinson Hyperlegible Next"/>
                 <a:ea typeface="Calibri"/>
                 <a:cs typeface="Calibri"/>
                 <a:sym typeface="Calibri"/>
@@ -964,7 +964,7 @@
                 <a:solidFill>
                   <a:schemeClr val="dk1"/>
                 </a:solidFill>
-                <a:latin typeface="Calibri"/>
+                <a:latin typeface="Atkinson Hyperlegible Next"/>
                 <a:ea typeface="Calibri"/>
                 <a:cs typeface="Calibri"/>
                 <a:sym typeface="Calibri"/>
@@ -990,7 +990,7 @@
                 <a:solidFill>
                   <a:schemeClr val="dk1"/>
                 </a:solidFill>
-                <a:latin typeface="Calibri"/>
+                <a:latin typeface="Atkinson Hyperlegible Next"/>
                 <a:ea typeface="Calibri"/>
                 <a:cs typeface="Calibri"/>
                 <a:sym typeface="Calibri"/>
@@ -1016,7 +1016,7 @@
                 <a:solidFill>
                   <a:schemeClr val="dk1"/>
                 </a:solidFill>
-                <a:latin typeface="Calibri"/>
+                <a:latin typeface="Atkinson Hyperlegible Next"/>
                 <a:ea typeface="Calibri"/>
                 <a:cs typeface="Calibri"/>
                 <a:sym typeface="Calibri"/>
@@ -1042,7 +1042,7 @@
                 <a:solidFill>
                   <a:schemeClr val="dk1"/>
                 </a:solidFill>
-                <a:latin typeface="Calibri"/>
+                <a:latin typeface="Atkinson Hyperlegible Next"/>
                 <a:ea typeface="Calibri"/>
                 <a:cs typeface="Calibri"/>
                 <a:sym typeface="Calibri"/>
@@ -1068,7 +1068,7 @@
                 <a:solidFill>
                   <a:schemeClr val="dk1"/>
                 </a:solidFill>
-                <a:latin typeface="Calibri"/>
+                <a:latin typeface="Atkinson Hyperlegible Next"/>
                 <a:ea typeface="Calibri"/>
                 <a:cs typeface="Calibri"/>
                 <a:sym typeface="Calibri"/>
@@ -1094,7 +1094,7 @@
                 <a:solidFill>
                   <a:schemeClr val="dk1"/>
                 </a:solidFill>
-                <a:latin typeface="Calibri"/>
+                <a:latin typeface="Atkinson Hyperlegible Next"/>
                 <a:ea typeface="Calibri"/>
                 <a:cs typeface="Calibri"/>
                 <a:sym typeface="Calibri"/>
@@ -1120,7 +1120,7 @@
                 <a:solidFill>
                   <a:schemeClr val="dk1"/>
                 </a:solidFill>
-                <a:latin typeface="Calibri"/>
+                <a:latin typeface="Atkinson Hyperlegible Next"/>
                 <a:ea typeface="Calibri"/>
                 <a:cs typeface="Calibri"/>
                 <a:sym typeface="Calibri"/>
@@ -1146,7 +1146,7 @@
                 <a:solidFill>
                   <a:schemeClr val="dk1"/>
                 </a:solidFill>
-                <a:latin typeface="Calibri"/>
+                <a:latin typeface="Atkinson Hyperlegible Next"/>
                 <a:ea typeface="Calibri"/>
                 <a:cs typeface="Calibri"/>
                 <a:sym typeface="Calibri"/>
@@ -1206,7 +1206,7 @@
                 <a:solidFill>
                   <a:schemeClr val="dk1"/>
                 </a:solidFill>
-                <a:latin typeface="Calibri"/>
+                <a:latin typeface="Atkinson Hyperlegible Next"/>
                 <a:ea typeface="Calibri"/>
                 <a:cs typeface="Calibri"/>
                 <a:sym typeface="Calibri"/>
@@ -1232,7 +1232,7 @@
                 <a:solidFill>
                   <a:schemeClr val="dk1"/>
                 </a:solidFill>
-                <a:latin typeface="Calibri"/>
+                <a:latin typeface="Atkinson Hyperlegible Next"/>
                 <a:ea typeface="Calibri"/>
                 <a:cs typeface="Calibri"/>
                 <a:sym typeface="Calibri"/>
@@ -1258,7 +1258,7 @@
                 <a:solidFill>
                   <a:schemeClr val="dk1"/>
                 </a:solidFill>
-                <a:latin typeface="Calibri"/>
+                <a:latin typeface="Atkinson Hyperlegible Next"/>
                 <a:ea typeface="Calibri"/>
                 <a:cs typeface="Calibri"/>
                 <a:sym typeface="Calibri"/>
@@ -1284,7 +1284,7 @@
                 <a:solidFill>
                   <a:schemeClr val="dk1"/>
                 </a:solidFill>
-                <a:latin typeface="Calibri"/>
+                <a:latin typeface="Atkinson Hyperlegible Next"/>
                 <a:ea typeface="Calibri"/>
                 <a:cs typeface="Calibri"/>
                 <a:sym typeface="Calibri"/>
@@ -1310,7 +1310,7 @@
                 <a:solidFill>
                   <a:schemeClr val="dk1"/>
                 </a:solidFill>
-                <a:latin typeface="Calibri"/>
+                <a:latin typeface="Atkinson Hyperlegible Next"/>
                 <a:ea typeface="Calibri"/>
                 <a:cs typeface="Calibri"/>
                 <a:sym typeface="Calibri"/>
@@ -1336,7 +1336,7 @@
                 <a:solidFill>
                   <a:schemeClr val="dk1"/>
                 </a:solidFill>
-                <a:latin typeface="Calibri"/>
+                <a:latin typeface="Atkinson Hyperlegible Next"/>
                 <a:ea typeface="Calibri"/>
                 <a:cs typeface="Calibri"/>
                 <a:sym typeface="Calibri"/>
@@ -1362,7 +1362,7 @@
                 <a:solidFill>
                   <a:schemeClr val="dk1"/>
                 </a:solidFill>
-                <a:latin typeface="Calibri"/>
+                <a:latin typeface="Atkinson Hyperlegible Next"/>
                 <a:ea typeface="Calibri"/>
                 <a:cs typeface="Calibri"/>
                 <a:sym typeface="Calibri"/>
@@ -1388,7 +1388,7 @@
                 <a:solidFill>
                   <a:schemeClr val="dk1"/>
                 </a:solidFill>
-                <a:latin typeface="Calibri"/>
+                <a:latin typeface="Atkinson Hyperlegible Next"/>
                 <a:ea typeface="Calibri"/>
                 <a:cs typeface="Calibri"/>
                 <a:sym typeface="Calibri"/>
@@ -1414,7 +1414,7 @@
                 <a:solidFill>
                   <a:schemeClr val="dk1"/>
                 </a:solidFill>
-                <a:latin typeface="Calibri"/>
+                <a:latin typeface="Atkinson Hyperlegible Next"/>
                 <a:ea typeface="Calibri"/>
                 <a:cs typeface="Calibri"/>
                 <a:sym typeface="Calibri"/>
@@ -1477,7 +1477,7 @@
                 <a:solidFill>
                   <a:schemeClr val="dk1"/>
                 </a:solidFill>
-                <a:latin typeface="Calibri"/>
+                <a:latin typeface="Atkinson Hyperlegible Next"/>
                 <a:ea typeface="Calibri"/>
                 <a:cs typeface="Calibri"/>
                 <a:sym typeface="Calibri"/>
@@ -1488,7 +1488,7 @@
               <a:solidFill>
                 <a:schemeClr val="dk1"/>
               </a:solidFill>
-              <a:latin typeface="Calibri"/>
+              <a:latin typeface="Atkinson Hyperlegible Next"/>
               <a:ea typeface="Calibri"/>
               <a:cs typeface="Calibri"/>
               <a:sym typeface="Calibri"/>
@@ -1529,7 +1529,7 @@
         <a:solidFill>
           <a:srgbClr val="000000"/>
         </a:solidFill>
-        <a:latin typeface="Arial"/>
+        <a:latin typeface="Atkinson Hyperlegible Next"/>
         <a:ea typeface="Arial"/>
         <a:cs typeface="Arial"/>
         <a:sym typeface="Arial"/>
@@ -1553,7 +1553,7 @@
         <a:solidFill>
           <a:srgbClr val="000000"/>
         </a:solidFill>
-        <a:latin typeface="Arial"/>
+        <a:latin typeface="Atkinson Hyperlegible Next"/>
         <a:ea typeface="Arial"/>
         <a:cs typeface="Arial"/>
         <a:sym typeface="Arial"/>
@@ -1577,7 +1577,7 @@
         <a:solidFill>
           <a:srgbClr val="000000"/>
         </a:solidFill>
-        <a:latin typeface="Arial"/>
+        <a:latin typeface="Atkinson Hyperlegible Next"/>
         <a:ea typeface="Arial"/>
         <a:cs typeface="Arial"/>
         <a:sym typeface="Arial"/>
@@ -1601,7 +1601,7 @@
         <a:solidFill>
           <a:srgbClr val="000000"/>
         </a:solidFill>
-        <a:latin typeface="Arial"/>
+        <a:latin typeface="Atkinson Hyperlegible Next"/>
         <a:ea typeface="Arial"/>
         <a:cs typeface="Arial"/>
         <a:sym typeface="Arial"/>
@@ -1625,7 +1625,7 @@
         <a:solidFill>
           <a:srgbClr val="000000"/>
         </a:solidFill>
-        <a:latin typeface="Arial"/>
+        <a:latin typeface="Atkinson Hyperlegible Next"/>
         <a:ea typeface="Arial"/>
         <a:cs typeface="Arial"/>
         <a:sym typeface="Arial"/>
@@ -1649,7 +1649,7 @@
         <a:solidFill>
           <a:srgbClr val="000000"/>
         </a:solidFill>
-        <a:latin typeface="Arial"/>
+        <a:latin typeface="Atkinson Hyperlegible Next"/>
         <a:ea typeface="Arial"/>
         <a:cs typeface="Arial"/>
         <a:sym typeface="Arial"/>
@@ -1673,7 +1673,7 @@
         <a:solidFill>
           <a:srgbClr val="000000"/>
         </a:solidFill>
-        <a:latin typeface="Arial"/>
+        <a:latin typeface="Atkinson Hyperlegible Next"/>
         <a:ea typeface="Arial"/>
         <a:cs typeface="Arial"/>
         <a:sym typeface="Arial"/>
@@ -1697,7 +1697,7 @@
         <a:solidFill>
           <a:srgbClr val="000000"/>
         </a:solidFill>
-        <a:latin typeface="Arial"/>
+        <a:latin typeface="Atkinson Hyperlegible Next"/>
         <a:ea typeface="Arial"/>
         <a:cs typeface="Arial"/>
         <a:sym typeface="Arial"/>
@@ -1721,7 +1721,7 @@
         <a:solidFill>
           <a:srgbClr val="000000"/>
         </a:solidFill>
-        <a:latin typeface="Arial"/>
+        <a:latin typeface="Atkinson Hyperlegible Next"/>
         <a:ea typeface="Arial"/>
         <a:cs typeface="Arial"/>
         <a:sym typeface="Arial"/>
@@ -5926,7 +5926,7 @@
                 <a:solidFill>
                   <a:srgbClr val="888888"/>
                 </a:solidFill>
-                <a:latin typeface="Calibri"/>
+                <a:latin typeface="Atkinson Hyperlegible Next"/>
                 <a:ea typeface="Calibri"/>
                 <a:cs typeface="Calibri"/>
                 <a:sym typeface="Calibri"/>
@@ -5952,7 +5952,7 @@
                 <a:solidFill>
                   <a:srgbClr val="888888"/>
                 </a:solidFill>
-                <a:latin typeface="Calibri"/>
+                <a:latin typeface="Atkinson Hyperlegible Next"/>
                 <a:ea typeface="Calibri"/>
                 <a:cs typeface="Calibri"/>
                 <a:sym typeface="Calibri"/>
@@ -5978,7 +5978,7 @@
                 <a:solidFill>
                   <a:srgbClr val="888888"/>
                 </a:solidFill>
-                <a:latin typeface="Calibri"/>
+                <a:latin typeface="Atkinson Hyperlegible Next"/>
                 <a:ea typeface="Calibri"/>
                 <a:cs typeface="Calibri"/>
                 <a:sym typeface="Calibri"/>
@@ -6004,7 +6004,7 @@
                 <a:solidFill>
                   <a:srgbClr val="888888"/>
                 </a:solidFill>
-                <a:latin typeface="Calibri"/>
+                <a:latin typeface="Atkinson Hyperlegible Next"/>
                 <a:ea typeface="Calibri"/>
                 <a:cs typeface="Calibri"/>
                 <a:sym typeface="Calibri"/>
@@ -6030,7 +6030,7 @@
                 <a:solidFill>
                   <a:srgbClr val="888888"/>
                 </a:solidFill>
-                <a:latin typeface="Calibri"/>
+                <a:latin typeface="Atkinson Hyperlegible Next"/>
                 <a:ea typeface="Calibri"/>
                 <a:cs typeface="Calibri"/>
                 <a:sym typeface="Calibri"/>
@@ -6056,7 +6056,7 @@
                 <a:solidFill>
                   <a:srgbClr val="888888"/>
                 </a:solidFill>
-                <a:latin typeface="Calibri"/>
+                <a:latin typeface="Atkinson Hyperlegible Next"/>
                 <a:ea typeface="Calibri"/>
                 <a:cs typeface="Calibri"/>
                 <a:sym typeface="Calibri"/>
@@ -6082,7 +6082,7 @@
                 <a:solidFill>
                   <a:srgbClr val="888888"/>
                 </a:solidFill>
-                <a:latin typeface="Calibri"/>
+                <a:latin typeface="Atkinson Hyperlegible Next"/>
                 <a:ea typeface="Calibri"/>
                 <a:cs typeface="Calibri"/>
                 <a:sym typeface="Calibri"/>
@@ -6108,7 +6108,7 @@
                 <a:solidFill>
                   <a:srgbClr val="888888"/>
                 </a:solidFill>
-                <a:latin typeface="Calibri"/>
+                <a:latin typeface="Atkinson Hyperlegible Next"/>
                 <a:ea typeface="Calibri"/>
                 <a:cs typeface="Calibri"/>
                 <a:sym typeface="Calibri"/>
@@ -6134,7 +6134,7 @@
                 <a:solidFill>
                   <a:srgbClr val="888888"/>
                 </a:solidFill>
-                <a:latin typeface="Calibri"/>
+                <a:latin typeface="Atkinson Hyperlegible Next"/>
                 <a:ea typeface="Calibri"/>
                 <a:cs typeface="Calibri"/>
                 <a:sym typeface="Calibri"/>
@@ -6902,7 +6902,7 @@
                 <a:solidFill>
                   <a:srgbClr val="888888"/>
                 </a:solidFill>
-                <a:latin typeface="Calibri"/>
+                <a:latin typeface="Atkinson Hyperlegible Next"/>
                 <a:ea typeface="Calibri"/>
                 <a:cs typeface="Calibri"/>
                 <a:sym typeface="Calibri"/>
@@ -6928,7 +6928,7 @@
                 <a:solidFill>
                   <a:srgbClr val="888888"/>
                 </a:solidFill>
-                <a:latin typeface="Calibri"/>
+                <a:latin typeface="Atkinson Hyperlegible Next"/>
                 <a:ea typeface="Calibri"/>
                 <a:cs typeface="Calibri"/>
                 <a:sym typeface="Calibri"/>
@@ -6954,7 +6954,7 @@
                 <a:solidFill>
                   <a:srgbClr val="888888"/>
                 </a:solidFill>
-                <a:latin typeface="Calibri"/>
+                <a:latin typeface="Atkinson Hyperlegible Next"/>
                 <a:ea typeface="Calibri"/>
                 <a:cs typeface="Calibri"/>
                 <a:sym typeface="Calibri"/>
@@ -6980,7 +6980,7 @@
                 <a:solidFill>
                   <a:srgbClr val="888888"/>
                 </a:solidFill>
-                <a:latin typeface="Calibri"/>
+                <a:latin typeface="Atkinson Hyperlegible Next"/>
                 <a:ea typeface="Calibri"/>
                 <a:cs typeface="Calibri"/>
                 <a:sym typeface="Calibri"/>
@@ -7006,7 +7006,7 @@
                 <a:solidFill>
                   <a:srgbClr val="888888"/>
                 </a:solidFill>
-                <a:latin typeface="Calibri"/>
+                <a:latin typeface="Atkinson Hyperlegible Next"/>
                 <a:ea typeface="Calibri"/>
                 <a:cs typeface="Calibri"/>
                 <a:sym typeface="Calibri"/>
@@ -7032,7 +7032,7 @@
                 <a:solidFill>
                   <a:srgbClr val="888888"/>
                 </a:solidFill>
-                <a:latin typeface="Calibri"/>
+                <a:latin typeface="Atkinson Hyperlegible Next"/>
                 <a:ea typeface="Calibri"/>
                 <a:cs typeface="Calibri"/>
                 <a:sym typeface="Calibri"/>
@@ -7058,7 +7058,7 @@
                 <a:solidFill>
                   <a:srgbClr val="888888"/>
                 </a:solidFill>
-                <a:latin typeface="Calibri"/>
+                <a:latin typeface="Atkinson Hyperlegible Next"/>
                 <a:ea typeface="Calibri"/>
                 <a:cs typeface="Calibri"/>
                 <a:sym typeface="Calibri"/>
@@ -7084,7 +7084,7 @@
                 <a:solidFill>
                   <a:srgbClr val="888888"/>
                 </a:solidFill>
-                <a:latin typeface="Calibri"/>
+                <a:latin typeface="Atkinson Hyperlegible Next"/>
                 <a:ea typeface="Calibri"/>
                 <a:cs typeface="Calibri"/>
                 <a:sym typeface="Calibri"/>
@@ -7110,7 +7110,7 @@
                 <a:solidFill>
                   <a:srgbClr val="888888"/>
                 </a:solidFill>
-                <a:latin typeface="Calibri"/>
+                <a:latin typeface="Atkinson Hyperlegible Next"/>
                 <a:ea typeface="Calibri"/>
                 <a:cs typeface="Calibri"/>
                 <a:sym typeface="Calibri"/>
@@ -7878,7 +7878,7 @@
                 <a:solidFill>
                   <a:srgbClr val="888888"/>
                 </a:solidFill>
-                <a:latin typeface="Calibri"/>
+                <a:latin typeface="Atkinson Hyperlegible Next"/>
                 <a:ea typeface="Calibri"/>
                 <a:cs typeface="Calibri"/>
                 <a:sym typeface="Calibri"/>
@@ -7904,7 +7904,7 @@
                 <a:solidFill>
                   <a:srgbClr val="888888"/>
                 </a:solidFill>
-                <a:latin typeface="Calibri"/>
+                <a:latin typeface="Atkinson Hyperlegible Next"/>
                 <a:ea typeface="Calibri"/>
                 <a:cs typeface="Calibri"/>
                 <a:sym typeface="Calibri"/>
@@ -7930,7 +7930,7 @@
                 <a:solidFill>
                   <a:srgbClr val="888888"/>
                 </a:solidFill>
-                <a:latin typeface="Calibri"/>
+                <a:latin typeface="Atkinson Hyperlegible Next"/>
                 <a:ea typeface="Calibri"/>
                 <a:cs typeface="Calibri"/>
                 <a:sym typeface="Calibri"/>
@@ -7956,7 +7956,7 @@
                 <a:solidFill>
                   <a:srgbClr val="888888"/>
                 </a:solidFill>
-                <a:latin typeface="Calibri"/>
+                <a:latin typeface="Atkinson Hyperlegible Next"/>
                 <a:ea typeface="Calibri"/>
                 <a:cs typeface="Calibri"/>
                 <a:sym typeface="Calibri"/>
@@ -7982,7 +7982,7 @@
                 <a:solidFill>
                   <a:srgbClr val="888888"/>
                 </a:solidFill>
-                <a:latin typeface="Calibri"/>
+                <a:latin typeface="Atkinson Hyperlegible Next"/>
                 <a:ea typeface="Calibri"/>
                 <a:cs typeface="Calibri"/>
                 <a:sym typeface="Calibri"/>
@@ -8008,7 +8008,7 @@
                 <a:solidFill>
                   <a:srgbClr val="888888"/>
                 </a:solidFill>
-                <a:latin typeface="Calibri"/>
+                <a:latin typeface="Atkinson Hyperlegible Next"/>
                 <a:ea typeface="Calibri"/>
                 <a:cs typeface="Calibri"/>
                 <a:sym typeface="Calibri"/>
@@ -8034,7 +8034,7 @@
                 <a:solidFill>
                   <a:srgbClr val="888888"/>
                 </a:solidFill>
-                <a:latin typeface="Calibri"/>
+                <a:latin typeface="Atkinson Hyperlegible Next"/>
                 <a:ea typeface="Calibri"/>
                 <a:cs typeface="Calibri"/>
                 <a:sym typeface="Calibri"/>
@@ -8060,7 +8060,7 @@
                 <a:solidFill>
                   <a:srgbClr val="888888"/>
                 </a:solidFill>
-                <a:latin typeface="Calibri"/>
+                <a:latin typeface="Atkinson Hyperlegible Next"/>
                 <a:ea typeface="Calibri"/>
                 <a:cs typeface="Calibri"/>
                 <a:sym typeface="Calibri"/>
@@ -8086,7 +8086,7 @@
                 <a:solidFill>
                   <a:srgbClr val="888888"/>
                 </a:solidFill>
-                <a:latin typeface="Calibri"/>
+                <a:latin typeface="Atkinson Hyperlegible Next"/>
                 <a:ea typeface="Calibri"/>
                 <a:cs typeface="Calibri"/>
                 <a:sym typeface="Calibri"/>
@@ -8891,7 +8891,7 @@
                 <a:solidFill>
                   <a:srgbClr val="888888"/>
                 </a:solidFill>
-                <a:latin typeface="Calibri"/>
+                <a:latin typeface="Atkinson Hyperlegible Next"/>
                 <a:ea typeface="Calibri"/>
                 <a:cs typeface="Calibri"/>
                 <a:sym typeface="Calibri"/>
@@ -8917,7 +8917,7 @@
                 <a:solidFill>
                   <a:srgbClr val="888888"/>
                 </a:solidFill>
-                <a:latin typeface="Calibri"/>
+                <a:latin typeface="Atkinson Hyperlegible Next"/>
                 <a:ea typeface="Calibri"/>
                 <a:cs typeface="Calibri"/>
                 <a:sym typeface="Calibri"/>
@@ -8943,7 +8943,7 @@
                 <a:solidFill>
                   <a:srgbClr val="888888"/>
                 </a:solidFill>
-                <a:latin typeface="Calibri"/>
+                <a:latin typeface="Atkinson Hyperlegible Next"/>
                 <a:ea typeface="Calibri"/>
                 <a:cs typeface="Calibri"/>
                 <a:sym typeface="Calibri"/>
@@ -8969,7 +8969,7 @@
                 <a:solidFill>
                   <a:srgbClr val="888888"/>
                 </a:solidFill>
-                <a:latin typeface="Calibri"/>
+                <a:latin typeface="Atkinson Hyperlegible Next"/>
                 <a:ea typeface="Calibri"/>
                 <a:cs typeface="Calibri"/>
                 <a:sym typeface="Calibri"/>
@@ -8995,7 +8995,7 @@
                 <a:solidFill>
                   <a:srgbClr val="888888"/>
                 </a:solidFill>
-                <a:latin typeface="Calibri"/>
+                <a:latin typeface="Atkinson Hyperlegible Next"/>
                 <a:ea typeface="Calibri"/>
                 <a:cs typeface="Calibri"/>
                 <a:sym typeface="Calibri"/>
@@ -9021,7 +9021,7 @@
                 <a:solidFill>
                   <a:srgbClr val="888888"/>
                 </a:solidFill>
-                <a:latin typeface="Calibri"/>
+                <a:latin typeface="Atkinson Hyperlegible Next"/>
                 <a:ea typeface="Calibri"/>
                 <a:cs typeface="Calibri"/>
                 <a:sym typeface="Calibri"/>
@@ -9047,7 +9047,7 @@
                 <a:solidFill>
                   <a:srgbClr val="888888"/>
                 </a:solidFill>
-                <a:latin typeface="Calibri"/>
+                <a:latin typeface="Atkinson Hyperlegible Next"/>
                 <a:ea typeface="Calibri"/>
                 <a:cs typeface="Calibri"/>
                 <a:sym typeface="Calibri"/>
@@ -9073,7 +9073,7 @@
                 <a:solidFill>
                   <a:srgbClr val="888888"/>
                 </a:solidFill>
-                <a:latin typeface="Calibri"/>
+                <a:latin typeface="Atkinson Hyperlegible Next"/>
                 <a:ea typeface="Calibri"/>
                 <a:cs typeface="Calibri"/>
                 <a:sym typeface="Calibri"/>
@@ -9099,7 +9099,7 @@
                 <a:solidFill>
                   <a:srgbClr val="888888"/>
                 </a:solidFill>
-                <a:latin typeface="Calibri"/>
+                <a:latin typeface="Atkinson Hyperlegible Next"/>
                 <a:ea typeface="Calibri"/>
                 <a:cs typeface="Calibri"/>
                 <a:sym typeface="Calibri"/>
@@ -10054,7 +10054,7 @@
                 <a:solidFill>
                   <a:srgbClr val="888888"/>
                 </a:solidFill>
-                <a:latin typeface="Calibri"/>
+                <a:latin typeface="Atkinson Hyperlegible Next"/>
                 <a:ea typeface="Calibri"/>
                 <a:cs typeface="Calibri"/>
                 <a:sym typeface="Calibri"/>
@@ -10080,7 +10080,7 @@
                 <a:solidFill>
                   <a:srgbClr val="888888"/>
                 </a:solidFill>
-                <a:latin typeface="Calibri"/>
+                <a:latin typeface="Atkinson Hyperlegible Next"/>
                 <a:ea typeface="Calibri"/>
                 <a:cs typeface="Calibri"/>
                 <a:sym typeface="Calibri"/>
@@ -10106,7 +10106,7 @@
                 <a:solidFill>
                   <a:srgbClr val="888888"/>
                 </a:solidFill>
-                <a:latin typeface="Calibri"/>
+                <a:latin typeface="Atkinson Hyperlegible Next"/>
                 <a:ea typeface="Calibri"/>
                 <a:cs typeface="Calibri"/>
                 <a:sym typeface="Calibri"/>
@@ -10132,7 +10132,7 @@
                 <a:solidFill>
                   <a:srgbClr val="888888"/>
                 </a:solidFill>
-                <a:latin typeface="Calibri"/>
+                <a:latin typeface="Atkinson Hyperlegible Next"/>
                 <a:ea typeface="Calibri"/>
                 <a:cs typeface="Calibri"/>
                 <a:sym typeface="Calibri"/>
@@ -10158,7 +10158,7 @@
                 <a:solidFill>
                   <a:srgbClr val="888888"/>
                 </a:solidFill>
-                <a:latin typeface="Calibri"/>
+                <a:latin typeface="Atkinson Hyperlegible Next"/>
                 <a:ea typeface="Calibri"/>
                 <a:cs typeface="Calibri"/>
                 <a:sym typeface="Calibri"/>
@@ -10184,7 +10184,7 @@
                 <a:solidFill>
                   <a:srgbClr val="888888"/>
                 </a:solidFill>
-                <a:latin typeface="Calibri"/>
+                <a:latin typeface="Atkinson Hyperlegible Next"/>
                 <a:ea typeface="Calibri"/>
                 <a:cs typeface="Calibri"/>
                 <a:sym typeface="Calibri"/>
@@ -10210,7 +10210,7 @@
                 <a:solidFill>
                   <a:srgbClr val="888888"/>
                 </a:solidFill>
-                <a:latin typeface="Calibri"/>
+                <a:latin typeface="Atkinson Hyperlegible Next"/>
                 <a:ea typeface="Calibri"/>
                 <a:cs typeface="Calibri"/>
                 <a:sym typeface="Calibri"/>
@@ -10236,7 +10236,7 @@
                 <a:solidFill>
                   <a:srgbClr val="888888"/>
                 </a:solidFill>
-                <a:latin typeface="Calibri"/>
+                <a:latin typeface="Atkinson Hyperlegible Next"/>
                 <a:ea typeface="Calibri"/>
                 <a:cs typeface="Calibri"/>
                 <a:sym typeface="Calibri"/>
@@ -10262,7 +10262,7 @@
                 <a:solidFill>
                   <a:srgbClr val="888888"/>
                 </a:solidFill>
-                <a:latin typeface="Calibri"/>
+                <a:latin typeface="Atkinson Hyperlegible Next"/>
                 <a:ea typeface="Calibri"/>
                 <a:cs typeface="Calibri"/>
                 <a:sym typeface="Calibri"/>
@@ -11591,7 +11591,7 @@
                 <a:solidFill>
                   <a:srgbClr val="888888"/>
                 </a:solidFill>
-                <a:latin typeface="Calibri"/>
+                <a:latin typeface="Atkinson Hyperlegible Next"/>
                 <a:ea typeface="Calibri"/>
                 <a:cs typeface="Calibri"/>
                 <a:sym typeface="Calibri"/>
@@ -11617,7 +11617,7 @@
                 <a:solidFill>
                   <a:srgbClr val="888888"/>
                 </a:solidFill>
-                <a:latin typeface="Calibri"/>
+                <a:latin typeface="Atkinson Hyperlegible Next"/>
                 <a:ea typeface="Calibri"/>
                 <a:cs typeface="Calibri"/>
                 <a:sym typeface="Calibri"/>
@@ -11643,7 +11643,7 @@
                 <a:solidFill>
                   <a:srgbClr val="888888"/>
                 </a:solidFill>
-                <a:latin typeface="Calibri"/>
+                <a:latin typeface="Atkinson Hyperlegible Next"/>
                 <a:ea typeface="Calibri"/>
                 <a:cs typeface="Calibri"/>
                 <a:sym typeface="Calibri"/>
@@ -11669,7 +11669,7 @@
                 <a:solidFill>
                   <a:srgbClr val="888888"/>
                 </a:solidFill>
-                <a:latin typeface="Calibri"/>
+                <a:latin typeface="Atkinson Hyperlegible Next"/>
                 <a:ea typeface="Calibri"/>
                 <a:cs typeface="Calibri"/>
                 <a:sym typeface="Calibri"/>
@@ -11695,7 +11695,7 @@
                 <a:solidFill>
                   <a:srgbClr val="888888"/>
                 </a:solidFill>
-                <a:latin typeface="Calibri"/>
+                <a:latin typeface="Atkinson Hyperlegible Next"/>
                 <a:ea typeface="Calibri"/>
                 <a:cs typeface="Calibri"/>
                 <a:sym typeface="Calibri"/>
@@ -11721,7 +11721,7 @@
                 <a:solidFill>
                   <a:srgbClr val="888888"/>
                 </a:solidFill>
-                <a:latin typeface="Calibri"/>
+                <a:latin typeface="Atkinson Hyperlegible Next"/>
                 <a:ea typeface="Calibri"/>
                 <a:cs typeface="Calibri"/>
                 <a:sym typeface="Calibri"/>
@@ -11747,7 +11747,7 @@
                 <a:solidFill>
                   <a:srgbClr val="888888"/>
                 </a:solidFill>
-                <a:latin typeface="Calibri"/>
+                <a:latin typeface="Atkinson Hyperlegible Next"/>
                 <a:ea typeface="Calibri"/>
                 <a:cs typeface="Calibri"/>
                 <a:sym typeface="Calibri"/>
@@ -11773,7 +11773,7 @@
                 <a:solidFill>
                   <a:srgbClr val="888888"/>
                 </a:solidFill>
-                <a:latin typeface="Calibri"/>
+                <a:latin typeface="Atkinson Hyperlegible Next"/>
                 <a:ea typeface="Calibri"/>
                 <a:cs typeface="Calibri"/>
                 <a:sym typeface="Calibri"/>
@@ -11799,7 +11799,7 @@
                 <a:solidFill>
                   <a:srgbClr val="888888"/>
                 </a:solidFill>
-                <a:latin typeface="Calibri"/>
+                <a:latin typeface="Atkinson Hyperlegible Next"/>
                 <a:ea typeface="Calibri"/>
                 <a:cs typeface="Calibri"/>
                 <a:sym typeface="Calibri"/>
@@ -12380,7 +12380,7 @@
                 <a:solidFill>
                   <a:srgbClr val="888888"/>
                 </a:solidFill>
-                <a:latin typeface="Calibri"/>
+                <a:latin typeface="Atkinson Hyperlegible Next"/>
                 <a:ea typeface="Calibri"/>
                 <a:cs typeface="Calibri"/>
                 <a:sym typeface="Calibri"/>
@@ -12406,7 +12406,7 @@
                 <a:solidFill>
                   <a:srgbClr val="888888"/>
                 </a:solidFill>
-                <a:latin typeface="Calibri"/>
+                <a:latin typeface="Atkinson Hyperlegible Next"/>
                 <a:ea typeface="Calibri"/>
                 <a:cs typeface="Calibri"/>
                 <a:sym typeface="Calibri"/>
@@ -12432,7 +12432,7 @@
                 <a:solidFill>
                   <a:srgbClr val="888888"/>
                 </a:solidFill>
-                <a:latin typeface="Calibri"/>
+                <a:latin typeface="Atkinson Hyperlegible Next"/>
                 <a:ea typeface="Calibri"/>
                 <a:cs typeface="Calibri"/>
                 <a:sym typeface="Calibri"/>
@@ -12458,7 +12458,7 @@
                 <a:solidFill>
                   <a:srgbClr val="888888"/>
                 </a:solidFill>
-                <a:latin typeface="Calibri"/>
+                <a:latin typeface="Atkinson Hyperlegible Next"/>
                 <a:ea typeface="Calibri"/>
                 <a:cs typeface="Calibri"/>
                 <a:sym typeface="Calibri"/>
@@ -12484,7 +12484,7 @@
                 <a:solidFill>
                   <a:srgbClr val="888888"/>
                 </a:solidFill>
-                <a:latin typeface="Calibri"/>
+                <a:latin typeface="Atkinson Hyperlegible Next"/>
                 <a:ea typeface="Calibri"/>
                 <a:cs typeface="Calibri"/>
                 <a:sym typeface="Calibri"/>
@@ -12510,7 +12510,7 @@
                 <a:solidFill>
                   <a:srgbClr val="888888"/>
                 </a:solidFill>
-                <a:latin typeface="Calibri"/>
+                <a:latin typeface="Atkinson Hyperlegible Next"/>
                 <a:ea typeface="Calibri"/>
                 <a:cs typeface="Calibri"/>
                 <a:sym typeface="Calibri"/>
@@ -12536,7 +12536,7 @@
                 <a:solidFill>
                   <a:srgbClr val="888888"/>
                 </a:solidFill>
-                <a:latin typeface="Calibri"/>
+                <a:latin typeface="Atkinson Hyperlegible Next"/>
                 <a:ea typeface="Calibri"/>
                 <a:cs typeface="Calibri"/>
                 <a:sym typeface="Calibri"/>
@@ -12562,7 +12562,7 @@
                 <a:solidFill>
                   <a:srgbClr val="888888"/>
                 </a:solidFill>
-                <a:latin typeface="Calibri"/>
+                <a:latin typeface="Atkinson Hyperlegible Next"/>
                 <a:ea typeface="Calibri"/>
                 <a:cs typeface="Calibri"/>
                 <a:sym typeface="Calibri"/>
@@ -12588,7 +12588,7 @@
                 <a:solidFill>
                   <a:srgbClr val="888888"/>
                 </a:solidFill>
-                <a:latin typeface="Calibri"/>
+                <a:latin typeface="Atkinson Hyperlegible Next"/>
                 <a:ea typeface="Calibri"/>
                 <a:cs typeface="Calibri"/>
                 <a:sym typeface="Calibri"/>
@@ -13544,7 +13544,7 @@
                 <a:solidFill>
                   <a:srgbClr val="888888"/>
                 </a:solidFill>
-                <a:latin typeface="Calibri"/>
+                <a:latin typeface="Atkinson Hyperlegible Next"/>
                 <a:ea typeface="Calibri"/>
                 <a:cs typeface="Calibri"/>
                 <a:sym typeface="Calibri"/>
@@ -13570,7 +13570,7 @@
                 <a:solidFill>
                   <a:srgbClr val="888888"/>
                 </a:solidFill>
-                <a:latin typeface="Calibri"/>
+                <a:latin typeface="Atkinson Hyperlegible Next"/>
                 <a:ea typeface="Calibri"/>
                 <a:cs typeface="Calibri"/>
                 <a:sym typeface="Calibri"/>
@@ -13596,7 +13596,7 @@
                 <a:solidFill>
                   <a:srgbClr val="888888"/>
                 </a:solidFill>
-                <a:latin typeface="Calibri"/>
+                <a:latin typeface="Atkinson Hyperlegible Next"/>
                 <a:ea typeface="Calibri"/>
                 <a:cs typeface="Calibri"/>
                 <a:sym typeface="Calibri"/>
@@ -13622,7 +13622,7 @@
                 <a:solidFill>
                   <a:srgbClr val="888888"/>
                 </a:solidFill>
-                <a:latin typeface="Calibri"/>
+                <a:latin typeface="Atkinson Hyperlegible Next"/>
                 <a:ea typeface="Calibri"/>
                 <a:cs typeface="Calibri"/>
                 <a:sym typeface="Calibri"/>
@@ -13648,7 +13648,7 @@
                 <a:solidFill>
                   <a:srgbClr val="888888"/>
                 </a:solidFill>
-                <a:latin typeface="Calibri"/>
+                <a:latin typeface="Atkinson Hyperlegible Next"/>
                 <a:ea typeface="Calibri"/>
                 <a:cs typeface="Calibri"/>
                 <a:sym typeface="Calibri"/>
@@ -13674,7 +13674,7 @@
                 <a:solidFill>
                   <a:srgbClr val="888888"/>
                 </a:solidFill>
-                <a:latin typeface="Calibri"/>
+                <a:latin typeface="Atkinson Hyperlegible Next"/>
                 <a:ea typeface="Calibri"/>
                 <a:cs typeface="Calibri"/>
                 <a:sym typeface="Calibri"/>
@@ -13700,7 +13700,7 @@
                 <a:solidFill>
                   <a:srgbClr val="888888"/>
                 </a:solidFill>
-                <a:latin typeface="Calibri"/>
+                <a:latin typeface="Atkinson Hyperlegible Next"/>
                 <a:ea typeface="Calibri"/>
                 <a:cs typeface="Calibri"/>
                 <a:sym typeface="Calibri"/>
@@ -13726,7 +13726,7 @@
                 <a:solidFill>
                   <a:srgbClr val="888888"/>
                 </a:solidFill>
-                <a:latin typeface="Calibri"/>
+                <a:latin typeface="Atkinson Hyperlegible Next"/>
                 <a:ea typeface="Calibri"/>
                 <a:cs typeface="Calibri"/>
                 <a:sym typeface="Calibri"/>
@@ -13752,7 +13752,7 @@
                 <a:solidFill>
                   <a:srgbClr val="888888"/>
                 </a:solidFill>
-                <a:latin typeface="Calibri"/>
+                <a:latin typeface="Atkinson Hyperlegible Next"/>
                 <a:ea typeface="Calibri"/>
                 <a:cs typeface="Calibri"/>
                 <a:sym typeface="Calibri"/>
@@ -14545,7 +14545,7 @@
                 <a:solidFill>
                   <a:srgbClr val="888888"/>
                 </a:solidFill>
-                <a:latin typeface="Calibri"/>
+                <a:latin typeface="Atkinson Hyperlegible Next"/>
                 <a:ea typeface="Calibri"/>
                 <a:cs typeface="Calibri"/>
                 <a:sym typeface="Calibri"/>
@@ -14571,7 +14571,7 @@
                 <a:solidFill>
                   <a:srgbClr val="888888"/>
                 </a:solidFill>
-                <a:latin typeface="Calibri"/>
+                <a:latin typeface="Atkinson Hyperlegible Next"/>
                 <a:ea typeface="Calibri"/>
                 <a:cs typeface="Calibri"/>
                 <a:sym typeface="Calibri"/>
@@ -14597,7 +14597,7 @@
                 <a:solidFill>
                   <a:srgbClr val="888888"/>
                 </a:solidFill>
-                <a:latin typeface="Calibri"/>
+                <a:latin typeface="Atkinson Hyperlegible Next"/>
                 <a:ea typeface="Calibri"/>
                 <a:cs typeface="Calibri"/>
                 <a:sym typeface="Calibri"/>
@@ -14623,7 +14623,7 @@
                 <a:solidFill>
                   <a:srgbClr val="888888"/>
                 </a:solidFill>
-                <a:latin typeface="Calibri"/>
+                <a:latin typeface="Atkinson Hyperlegible Next"/>
                 <a:ea typeface="Calibri"/>
                 <a:cs typeface="Calibri"/>
                 <a:sym typeface="Calibri"/>
@@ -14649,7 +14649,7 @@
                 <a:solidFill>
                   <a:srgbClr val="888888"/>
                 </a:solidFill>
-                <a:latin typeface="Calibri"/>
+                <a:latin typeface="Atkinson Hyperlegible Next"/>
                 <a:ea typeface="Calibri"/>
                 <a:cs typeface="Calibri"/>
                 <a:sym typeface="Calibri"/>
@@ -14675,7 +14675,7 @@
                 <a:solidFill>
                   <a:srgbClr val="888888"/>
                 </a:solidFill>
-                <a:latin typeface="Calibri"/>
+                <a:latin typeface="Atkinson Hyperlegible Next"/>
                 <a:ea typeface="Calibri"/>
                 <a:cs typeface="Calibri"/>
                 <a:sym typeface="Calibri"/>
@@ -14701,7 +14701,7 @@
                 <a:solidFill>
                   <a:srgbClr val="888888"/>
                 </a:solidFill>
-                <a:latin typeface="Calibri"/>
+                <a:latin typeface="Atkinson Hyperlegible Next"/>
                 <a:ea typeface="Calibri"/>
                 <a:cs typeface="Calibri"/>
                 <a:sym typeface="Calibri"/>
@@ -14727,7 +14727,7 @@
                 <a:solidFill>
                   <a:srgbClr val="888888"/>
                 </a:solidFill>
-                <a:latin typeface="Calibri"/>
+                <a:latin typeface="Atkinson Hyperlegible Next"/>
                 <a:ea typeface="Calibri"/>
                 <a:cs typeface="Calibri"/>
                 <a:sym typeface="Calibri"/>
@@ -14753,7 +14753,7 @@
                 <a:solidFill>
                   <a:srgbClr val="888888"/>
                 </a:solidFill>
-                <a:latin typeface="Calibri"/>
+                <a:latin typeface="Atkinson Hyperlegible Next"/>
                 <a:ea typeface="Calibri"/>
                 <a:cs typeface="Calibri"/>
                 <a:sym typeface="Calibri"/>
@@ -15521,7 +15521,7 @@
                 <a:solidFill>
                   <a:srgbClr val="888888"/>
                 </a:solidFill>
-                <a:latin typeface="Calibri"/>
+                <a:latin typeface="Atkinson Hyperlegible Next"/>
                 <a:ea typeface="Calibri"/>
                 <a:cs typeface="Calibri"/>
                 <a:sym typeface="Calibri"/>
@@ -15547,7 +15547,7 @@
                 <a:solidFill>
                   <a:srgbClr val="888888"/>
                 </a:solidFill>
-                <a:latin typeface="Calibri"/>
+                <a:latin typeface="Atkinson Hyperlegible Next"/>
                 <a:ea typeface="Calibri"/>
                 <a:cs typeface="Calibri"/>
                 <a:sym typeface="Calibri"/>
@@ -15573,7 +15573,7 @@
                 <a:solidFill>
                   <a:srgbClr val="888888"/>
                 </a:solidFill>
-                <a:latin typeface="Calibri"/>
+                <a:latin typeface="Atkinson Hyperlegible Next"/>
                 <a:ea typeface="Calibri"/>
                 <a:cs typeface="Calibri"/>
                 <a:sym typeface="Calibri"/>
@@ -15599,7 +15599,7 @@
                 <a:solidFill>
                   <a:srgbClr val="888888"/>
                 </a:solidFill>
-                <a:latin typeface="Calibri"/>
+                <a:latin typeface="Atkinson Hyperlegible Next"/>
                 <a:ea typeface="Calibri"/>
                 <a:cs typeface="Calibri"/>
                 <a:sym typeface="Calibri"/>
@@ -15625,7 +15625,7 @@
                 <a:solidFill>
                   <a:srgbClr val="888888"/>
                 </a:solidFill>
-                <a:latin typeface="Calibri"/>
+                <a:latin typeface="Atkinson Hyperlegible Next"/>
                 <a:ea typeface="Calibri"/>
                 <a:cs typeface="Calibri"/>
                 <a:sym typeface="Calibri"/>
@@ -15651,7 +15651,7 @@
                 <a:solidFill>
                   <a:srgbClr val="888888"/>
                 </a:solidFill>
-                <a:latin typeface="Calibri"/>
+                <a:latin typeface="Atkinson Hyperlegible Next"/>
                 <a:ea typeface="Calibri"/>
                 <a:cs typeface="Calibri"/>
                 <a:sym typeface="Calibri"/>
@@ -15677,7 +15677,7 @@
                 <a:solidFill>
                   <a:srgbClr val="888888"/>
                 </a:solidFill>
-                <a:latin typeface="Calibri"/>
+                <a:latin typeface="Atkinson Hyperlegible Next"/>
                 <a:ea typeface="Calibri"/>
                 <a:cs typeface="Calibri"/>
                 <a:sym typeface="Calibri"/>
@@ -15703,7 +15703,7 @@
                 <a:solidFill>
                   <a:srgbClr val="888888"/>
                 </a:solidFill>
-                <a:latin typeface="Calibri"/>
+                <a:latin typeface="Atkinson Hyperlegible Next"/>
                 <a:ea typeface="Calibri"/>
                 <a:cs typeface="Calibri"/>
                 <a:sym typeface="Calibri"/>
@@ -15729,7 +15729,7 @@
                 <a:solidFill>
                   <a:srgbClr val="888888"/>
                 </a:solidFill>
-                <a:latin typeface="Calibri"/>
+                <a:latin typeface="Atkinson Hyperlegible Next"/>
                 <a:ea typeface="Calibri"/>
                 <a:cs typeface="Calibri"/>
                 <a:sym typeface="Calibri"/>
@@ -15835,7 +15835,7 @@
                 <a:solidFill>
                   <a:schemeClr val="dk1"/>
                 </a:solidFill>
-                <a:latin typeface="Calibri"/>
+                <a:latin typeface="Atkinson Hyperlegible Next"/>
                 <a:ea typeface="Calibri"/>
                 <a:cs typeface="Calibri"/>
                 <a:sym typeface="Calibri"/>
@@ -15861,7 +15861,7 @@
                 <a:solidFill>
                   <a:srgbClr val="000000"/>
                 </a:solidFill>
-                <a:latin typeface="Arial"/>
+                <a:latin typeface="Atkinson Hyperlegible Next"/>
                 <a:ea typeface="Arial"/>
                 <a:cs typeface="Arial"/>
                 <a:sym typeface="Arial"/>
@@ -15887,7 +15887,7 @@
                 <a:solidFill>
                   <a:srgbClr val="000000"/>
                 </a:solidFill>
-                <a:latin typeface="Arial"/>
+                <a:latin typeface="Atkinson Hyperlegible Next"/>
                 <a:ea typeface="Arial"/>
                 <a:cs typeface="Arial"/>
                 <a:sym typeface="Arial"/>
@@ -15913,7 +15913,7 @@
                 <a:solidFill>
                   <a:srgbClr val="000000"/>
                 </a:solidFill>
-                <a:latin typeface="Arial"/>
+                <a:latin typeface="Atkinson Hyperlegible Next"/>
                 <a:ea typeface="Arial"/>
                 <a:cs typeface="Arial"/>
                 <a:sym typeface="Arial"/>
@@ -15939,7 +15939,7 @@
                 <a:solidFill>
                   <a:srgbClr val="000000"/>
                 </a:solidFill>
-                <a:latin typeface="Arial"/>
+                <a:latin typeface="Atkinson Hyperlegible Next"/>
                 <a:ea typeface="Arial"/>
                 <a:cs typeface="Arial"/>
                 <a:sym typeface="Arial"/>
@@ -15965,7 +15965,7 @@
                 <a:solidFill>
                   <a:srgbClr val="000000"/>
                 </a:solidFill>
-                <a:latin typeface="Arial"/>
+                <a:latin typeface="Atkinson Hyperlegible Next"/>
                 <a:ea typeface="Arial"/>
                 <a:cs typeface="Arial"/>
                 <a:sym typeface="Arial"/>
@@ -15991,7 +15991,7 @@
                 <a:solidFill>
                   <a:srgbClr val="000000"/>
                 </a:solidFill>
-                <a:latin typeface="Arial"/>
+                <a:latin typeface="Atkinson Hyperlegible Next"/>
                 <a:ea typeface="Arial"/>
                 <a:cs typeface="Arial"/>
                 <a:sym typeface="Arial"/>
@@ -16017,7 +16017,7 @@
                 <a:solidFill>
                   <a:srgbClr val="000000"/>
                 </a:solidFill>
-                <a:latin typeface="Arial"/>
+                <a:latin typeface="Atkinson Hyperlegible Next"/>
                 <a:ea typeface="Arial"/>
                 <a:cs typeface="Arial"/>
                 <a:sym typeface="Arial"/>
@@ -16043,7 +16043,7 @@
                 <a:solidFill>
                   <a:srgbClr val="000000"/>
                 </a:solidFill>
-                <a:latin typeface="Arial"/>
+                <a:latin typeface="Atkinson Hyperlegible Next"/>
                 <a:ea typeface="Arial"/>
                 <a:cs typeface="Arial"/>
                 <a:sym typeface="Arial"/>
@@ -16103,7 +16103,7 @@
                 <a:solidFill>
                   <a:schemeClr val="dk1"/>
                 </a:solidFill>
-                <a:latin typeface="Calibri"/>
+                <a:latin typeface="Atkinson Hyperlegible Next"/>
                 <a:ea typeface="Calibri"/>
                 <a:cs typeface="Calibri"/>
                 <a:sym typeface="Calibri"/>
@@ -16129,7 +16129,7 @@
                 <a:solidFill>
                   <a:schemeClr val="dk1"/>
                 </a:solidFill>
-                <a:latin typeface="Calibri"/>
+                <a:latin typeface="Atkinson Hyperlegible Next"/>
                 <a:ea typeface="Calibri"/>
                 <a:cs typeface="Calibri"/>
                 <a:sym typeface="Calibri"/>
@@ -16155,7 +16155,7 @@
                 <a:solidFill>
                   <a:schemeClr val="dk1"/>
                 </a:solidFill>
-                <a:latin typeface="Calibri"/>
+                <a:latin typeface="Atkinson Hyperlegible Next"/>
                 <a:ea typeface="Calibri"/>
                 <a:cs typeface="Calibri"/>
                 <a:sym typeface="Calibri"/>
@@ -16181,7 +16181,7 @@
                 <a:solidFill>
                   <a:schemeClr val="dk1"/>
                 </a:solidFill>
-                <a:latin typeface="Calibri"/>
+                <a:latin typeface="Atkinson Hyperlegible Next"/>
                 <a:ea typeface="Calibri"/>
                 <a:cs typeface="Calibri"/>
                 <a:sym typeface="Calibri"/>
@@ -16207,7 +16207,7 @@
                 <a:solidFill>
                   <a:schemeClr val="dk1"/>
                 </a:solidFill>
-                <a:latin typeface="Calibri"/>
+                <a:latin typeface="Atkinson Hyperlegible Next"/>
                 <a:ea typeface="Calibri"/>
                 <a:cs typeface="Calibri"/>
                 <a:sym typeface="Calibri"/>
@@ -16233,7 +16233,7 @@
                 <a:solidFill>
                   <a:schemeClr val="dk1"/>
                 </a:solidFill>
-                <a:latin typeface="Calibri"/>
+                <a:latin typeface="Atkinson Hyperlegible Next"/>
                 <a:ea typeface="Calibri"/>
                 <a:cs typeface="Calibri"/>
                 <a:sym typeface="Calibri"/>
@@ -16259,7 +16259,7 @@
                 <a:solidFill>
                   <a:schemeClr val="dk1"/>
                 </a:solidFill>
-                <a:latin typeface="Calibri"/>
+                <a:latin typeface="Atkinson Hyperlegible Next"/>
                 <a:ea typeface="Calibri"/>
                 <a:cs typeface="Calibri"/>
                 <a:sym typeface="Calibri"/>
@@ -16285,7 +16285,7 @@
                 <a:solidFill>
                   <a:schemeClr val="dk1"/>
                 </a:solidFill>
-                <a:latin typeface="Calibri"/>
+                <a:latin typeface="Atkinson Hyperlegible Next"/>
                 <a:ea typeface="Calibri"/>
                 <a:cs typeface="Calibri"/>
                 <a:sym typeface="Calibri"/>
@@ -16311,7 +16311,7 @@
                 <a:solidFill>
                   <a:schemeClr val="dk1"/>
                 </a:solidFill>
-                <a:latin typeface="Calibri"/>
+                <a:latin typeface="Atkinson Hyperlegible Next"/>
                 <a:ea typeface="Calibri"/>
                 <a:cs typeface="Calibri"/>
                 <a:sym typeface="Calibri"/>
@@ -16371,7 +16371,7 @@
                 <a:solidFill>
                   <a:srgbClr val="888888"/>
                 </a:solidFill>
-                <a:latin typeface="Calibri"/>
+                <a:latin typeface="Atkinson Hyperlegible Next"/>
                 <a:ea typeface="Calibri"/>
                 <a:cs typeface="Calibri"/>
                 <a:sym typeface="Calibri"/>
@@ -16397,7 +16397,7 @@
                 <a:solidFill>
                   <a:schemeClr val="dk1"/>
                 </a:solidFill>
-                <a:latin typeface="Calibri"/>
+                <a:latin typeface="Atkinson Hyperlegible Next"/>
                 <a:ea typeface="Calibri"/>
                 <a:cs typeface="Calibri"/>
                 <a:sym typeface="Calibri"/>
@@ -16423,7 +16423,7 @@
                 <a:solidFill>
                   <a:schemeClr val="dk1"/>
                 </a:solidFill>
-                <a:latin typeface="Calibri"/>
+                <a:latin typeface="Atkinson Hyperlegible Next"/>
                 <a:ea typeface="Calibri"/>
                 <a:cs typeface="Calibri"/>
                 <a:sym typeface="Calibri"/>
@@ -16449,7 +16449,7 @@
                 <a:solidFill>
                   <a:schemeClr val="dk1"/>
                 </a:solidFill>
-                <a:latin typeface="Calibri"/>
+                <a:latin typeface="Atkinson Hyperlegible Next"/>
                 <a:ea typeface="Calibri"/>
                 <a:cs typeface="Calibri"/>
                 <a:sym typeface="Calibri"/>
@@ -16475,7 +16475,7 @@
                 <a:solidFill>
                   <a:schemeClr val="dk1"/>
                 </a:solidFill>
-                <a:latin typeface="Calibri"/>
+                <a:latin typeface="Atkinson Hyperlegible Next"/>
                 <a:ea typeface="Calibri"/>
                 <a:cs typeface="Calibri"/>
                 <a:sym typeface="Calibri"/>
@@ -16501,7 +16501,7 @@
                 <a:solidFill>
                   <a:schemeClr val="dk1"/>
                 </a:solidFill>
-                <a:latin typeface="Calibri"/>
+                <a:latin typeface="Atkinson Hyperlegible Next"/>
                 <a:ea typeface="Calibri"/>
                 <a:cs typeface="Calibri"/>
                 <a:sym typeface="Calibri"/>
@@ -16527,7 +16527,7 @@
                 <a:solidFill>
                   <a:schemeClr val="dk1"/>
                 </a:solidFill>
-                <a:latin typeface="Calibri"/>
+                <a:latin typeface="Atkinson Hyperlegible Next"/>
                 <a:ea typeface="Calibri"/>
                 <a:cs typeface="Calibri"/>
                 <a:sym typeface="Calibri"/>
@@ -16553,7 +16553,7 @@
                 <a:solidFill>
                   <a:schemeClr val="dk1"/>
                 </a:solidFill>
-                <a:latin typeface="Calibri"/>
+                <a:latin typeface="Atkinson Hyperlegible Next"/>
                 <a:ea typeface="Calibri"/>
                 <a:cs typeface="Calibri"/>
                 <a:sym typeface="Calibri"/>
@@ -16579,7 +16579,7 @@
                 <a:solidFill>
                   <a:schemeClr val="dk1"/>
                 </a:solidFill>
-                <a:latin typeface="Calibri"/>
+                <a:latin typeface="Atkinson Hyperlegible Next"/>
                 <a:ea typeface="Calibri"/>
                 <a:cs typeface="Calibri"/>
                 <a:sym typeface="Calibri"/>
@@ -16639,7 +16639,7 @@
                 <a:solidFill>
                   <a:srgbClr val="888888"/>
                 </a:solidFill>
-                <a:latin typeface="Calibri"/>
+                <a:latin typeface="Atkinson Hyperlegible Next"/>
                 <a:ea typeface="Calibri"/>
                 <a:cs typeface="Calibri"/>
                 <a:sym typeface="Calibri"/>
@@ -16665,7 +16665,7 @@
                 <a:solidFill>
                   <a:schemeClr val="dk1"/>
                 </a:solidFill>
-                <a:latin typeface="Calibri"/>
+                <a:latin typeface="Atkinson Hyperlegible Next"/>
                 <a:ea typeface="Calibri"/>
                 <a:cs typeface="Calibri"/>
                 <a:sym typeface="Calibri"/>
@@ -16691,7 +16691,7 @@
                 <a:solidFill>
                   <a:schemeClr val="dk1"/>
                 </a:solidFill>
-                <a:latin typeface="Calibri"/>
+                <a:latin typeface="Atkinson Hyperlegible Next"/>
                 <a:ea typeface="Calibri"/>
                 <a:cs typeface="Calibri"/>
                 <a:sym typeface="Calibri"/>
@@ -16717,7 +16717,7 @@
                 <a:solidFill>
                   <a:schemeClr val="dk1"/>
                 </a:solidFill>
-                <a:latin typeface="Calibri"/>
+                <a:latin typeface="Atkinson Hyperlegible Next"/>
                 <a:ea typeface="Calibri"/>
                 <a:cs typeface="Calibri"/>
                 <a:sym typeface="Calibri"/>
@@ -16743,7 +16743,7 @@
                 <a:solidFill>
                   <a:schemeClr val="dk1"/>
                 </a:solidFill>
-                <a:latin typeface="Calibri"/>
+                <a:latin typeface="Atkinson Hyperlegible Next"/>
                 <a:ea typeface="Calibri"/>
                 <a:cs typeface="Calibri"/>
                 <a:sym typeface="Calibri"/>
@@ -16769,7 +16769,7 @@
                 <a:solidFill>
                   <a:schemeClr val="dk1"/>
                 </a:solidFill>
-                <a:latin typeface="Calibri"/>
+                <a:latin typeface="Atkinson Hyperlegible Next"/>
                 <a:ea typeface="Calibri"/>
                 <a:cs typeface="Calibri"/>
                 <a:sym typeface="Calibri"/>
@@ -16795,7 +16795,7 @@
                 <a:solidFill>
                   <a:schemeClr val="dk1"/>
                 </a:solidFill>
-                <a:latin typeface="Calibri"/>
+                <a:latin typeface="Atkinson Hyperlegible Next"/>
                 <a:ea typeface="Calibri"/>
                 <a:cs typeface="Calibri"/>
                 <a:sym typeface="Calibri"/>
@@ -16821,7 +16821,7 @@
                 <a:solidFill>
                   <a:schemeClr val="dk1"/>
                 </a:solidFill>
-                <a:latin typeface="Calibri"/>
+                <a:latin typeface="Atkinson Hyperlegible Next"/>
                 <a:ea typeface="Calibri"/>
                 <a:cs typeface="Calibri"/>
                 <a:sym typeface="Calibri"/>
@@ -16847,7 +16847,7 @@
                 <a:solidFill>
                   <a:schemeClr val="dk1"/>
                 </a:solidFill>
-                <a:latin typeface="Calibri"/>
+                <a:latin typeface="Atkinson Hyperlegible Next"/>
                 <a:ea typeface="Calibri"/>
                 <a:cs typeface="Calibri"/>
                 <a:sym typeface="Calibri"/>
@@ -16907,7 +16907,7 @@
                 <a:solidFill>
                   <a:srgbClr val="888888"/>
                 </a:solidFill>
-                <a:latin typeface="Calibri"/>
+                <a:latin typeface="Atkinson Hyperlegible Next"/>
                 <a:ea typeface="Calibri"/>
                 <a:cs typeface="Calibri"/>
                 <a:sym typeface="Calibri"/>
@@ -16933,7 +16933,7 @@
                 <a:solidFill>
                   <a:srgbClr val="888888"/>
                 </a:solidFill>
-                <a:latin typeface="Calibri"/>
+                <a:latin typeface="Atkinson Hyperlegible Next"/>
                 <a:ea typeface="Calibri"/>
                 <a:cs typeface="Calibri"/>
                 <a:sym typeface="Calibri"/>
@@ -16959,7 +16959,7 @@
                 <a:solidFill>
                   <a:srgbClr val="888888"/>
                 </a:solidFill>
-                <a:latin typeface="Calibri"/>
+                <a:latin typeface="Atkinson Hyperlegible Next"/>
                 <a:ea typeface="Calibri"/>
                 <a:cs typeface="Calibri"/>
                 <a:sym typeface="Calibri"/>
@@ -16985,7 +16985,7 @@
                 <a:solidFill>
                   <a:srgbClr val="888888"/>
                 </a:solidFill>
-                <a:latin typeface="Calibri"/>
+                <a:latin typeface="Atkinson Hyperlegible Next"/>
                 <a:ea typeface="Calibri"/>
                 <a:cs typeface="Calibri"/>
                 <a:sym typeface="Calibri"/>
@@ -17011,7 +17011,7 @@
                 <a:solidFill>
                   <a:srgbClr val="888888"/>
                 </a:solidFill>
-                <a:latin typeface="Calibri"/>
+                <a:latin typeface="Atkinson Hyperlegible Next"/>
                 <a:ea typeface="Calibri"/>
                 <a:cs typeface="Calibri"/>
                 <a:sym typeface="Calibri"/>
@@ -17037,7 +17037,7 @@
                 <a:solidFill>
                   <a:srgbClr val="888888"/>
                 </a:solidFill>
-                <a:latin typeface="Calibri"/>
+                <a:latin typeface="Atkinson Hyperlegible Next"/>
                 <a:ea typeface="Calibri"/>
                 <a:cs typeface="Calibri"/>
                 <a:sym typeface="Calibri"/>
@@ -17063,7 +17063,7 @@
                 <a:solidFill>
                   <a:srgbClr val="888888"/>
                 </a:solidFill>
-                <a:latin typeface="Calibri"/>
+                <a:latin typeface="Atkinson Hyperlegible Next"/>
                 <a:ea typeface="Calibri"/>
                 <a:cs typeface="Calibri"/>
                 <a:sym typeface="Calibri"/>
@@ -17089,7 +17089,7 @@
                 <a:solidFill>
                   <a:srgbClr val="888888"/>
                 </a:solidFill>
-                <a:latin typeface="Calibri"/>
+                <a:latin typeface="Atkinson Hyperlegible Next"/>
                 <a:ea typeface="Calibri"/>
                 <a:cs typeface="Calibri"/>
                 <a:sym typeface="Calibri"/>
@@ -17115,7 +17115,7 @@
                 <a:solidFill>
                   <a:srgbClr val="888888"/>
                 </a:solidFill>
-                <a:latin typeface="Calibri"/>
+                <a:latin typeface="Atkinson Hyperlegible Next"/>
                 <a:ea typeface="Calibri"/>
                 <a:cs typeface="Calibri"/>
                 <a:sym typeface="Calibri"/>
@@ -17187,7 +17187,7 @@
           <a:solidFill>
             <a:srgbClr val="000000"/>
           </a:solidFill>
-          <a:latin typeface="Arial"/>
+          <a:latin typeface="Atkinson Hyperlegible Next"/>
           <a:ea typeface="Arial"/>
           <a:cs typeface="Arial"/>
           <a:sym typeface="Arial"/>
@@ -17211,7 +17211,7 @@
           <a:solidFill>
             <a:srgbClr val="000000"/>
           </a:solidFill>
-          <a:latin typeface="Arial"/>
+          <a:latin typeface="Atkinson Hyperlegible Next"/>
           <a:ea typeface="Arial"/>
           <a:cs typeface="Arial"/>
           <a:sym typeface="Arial"/>
@@ -17235,7 +17235,7 @@
           <a:solidFill>
             <a:srgbClr val="000000"/>
           </a:solidFill>
-          <a:latin typeface="Arial"/>
+          <a:latin typeface="Atkinson Hyperlegible Next"/>
           <a:ea typeface="Arial"/>
           <a:cs typeface="Arial"/>
           <a:sym typeface="Arial"/>
@@ -17259,7 +17259,7 @@
           <a:solidFill>
             <a:srgbClr val="000000"/>
           </a:solidFill>
-          <a:latin typeface="Arial"/>
+          <a:latin typeface="Atkinson Hyperlegible Next"/>
           <a:ea typeface="Arial"/>
           <a:cs typeface="Arial"/>
           <a:sym typeface="Arial"/>
@@ -17283,7 +17283,7 @@
           <a:solidFill>
             <a:srgbClr val="000000"/>
           </a:solidFill>
-          <a:latin typeface="Arial"/>
+          <a:latin typeface="Atkinson Hyperlegible Next"/>
           <a:ea typeface="Arial"/>
           <a:cs typeface="Arial"/>
           <a:sym typeface="Arial"/>
@@ -17307,7 +17307,7 @@
           <a:solidFill>
             <a:srgbClr val="000000"/>
           </a:solidFill>
-          <a:latin typeface="Arial"/>
+          <a:latin typeface="Atkinson Hyperlegible Next"/>
           <a:ea typeface="Arial"/>
           <a:cs typeface="Arial"/>
           <a:sym typeface="Arial"/>
@@ -17331,7 +17331,7 @@
           <a:solidFill>
             <a:srgbClr val="000000"/>
           </a:solidFill>
-          <a:latin typeface="Arial"/>
+          <a:latin typeface="Atkinson Hyperlegible Next"/>
           <a:ea typeface="Arial"/>
           <a:cs typeface="Arial"/>
           <a:sym typeface="Arial"/>
@@ -17355,7 +17355,7 @@
           <a:solidFill>
             <a:srgbClr val="000000"/>
           </a:solidFill>
-          <a:latin typeface="Arial"/>
+          <a:latin typeface="Atkinson Hyperlegible Next"/>
           <a:ea typeface="Arial"/>
           <a:cs typeface="Arial"/>
           <a:sym typeface="Arial"/>
@@ -17379,7 +17379,7 @@
           <a:solidFill>
             <a:srgbClr val="000000"/>
           </a:solidFill>
-          <a:latin typeface="Arial"/>
+          <a:latin typeface="Atkinson Hyperlegible Next"/>
           <a:ea typeface="Arial"/>
           <a:cs typeface="Arial"/>
           <a:sym typeface="Arial"/>
@@ -17416,7 +17416,7 @@
           <a:solidFill>
             <a:srgbClr val="000000"/>
           </a:solidFill>
-          <a:latin typeface="Arial"/>
+          <a:latin typeface="Atkinson Hyperlegible Next"/>
           <a:ea typeface="Arial"/>
           <a:cs typeface="Arial"/>
           <a:sym typeface="Arial"/>
@@ -17440,7 +17440,7 @@
           <a:solidFill>
             <a:srgbClr val="000000"/>
           </a:solidFill>
-          <a:latin typeface="Arial"/>
+          <a:latin typeface="Atkinson Hyperlegible Next"/>
           <a:ea typeface="Arial"/>
           <a:cs typeface="Arial"/>
           <a:sym typeface="Arial"/>
@@ -17464,7 +17464,7 @@
           <a:solidFill>
             <a:srgbClr val="000000"/>
           </a:solidFill>
-          <a:latin typeface="Arial"/>
+          <a:latin typeface="Atkinson Hyperlegible Next"/>
           <a:ea typeface="Arial"/>
           <a:cs typeface="Arial"/>
           <a:sym typeface="Arial"/>
@@ -17488,7 +17488,7 @@
           <a:solidFill>
             <a:srgbClr val="000000"/>
           </a:solidFill>
-          <a:latin typeface="Arial"/>
+          <a:latin typeface="Atkinson Hyperlegible Next"/>
           <a:ea typeface="Arial"/>
           <a:cs typeface="Arial"/>
           <a:sym typeface="Arial"/>
@@ -17512,7 +17512,7 @@
           <a:solidFill>
             <a:srgbClr val="000000"/>
           </a:solidFill>
-          <a:latin typeface="Arial"/>
+          <a:latin typeface="Atkinson Hyperlegible Next"/>
           <a:ea typeface="Arial"/>
           <a:cs typeface="Arial"/>
           <a:sym typeface="Arial"/>
@@ -17536,7 +17536,7 @@
           <a:solidFill>
             <a:srgbClr val="000000"/>
           </a:solidFill>
-          <a:latin typeface="Arial"/>
+          <a:latin typeface="Atkinson Hyperlegible Next"/>
           <a:ea typeface="Arial"/>
           <a:cs typeface="Arial"/>
           <a:sym typeface="Arial"/>
@@ -17560,7 +17560,7 @@
           <a:solidFill>
             <a:srgbClr val="000000"/>
           </a:solidFill>
-          <a:latin typeface="Arial"/>
+          <a:latin typeface="Atkinson Hyperlegible Next"/>
           <a:ea typeface="Arial"/>
           <a:cs typeface="Arial"/>
           <a:sym typeface="Arial"/>
@@ -17584,7 +17584,7 @@
           <a:solidFill>
             <a:srgbClr val="000000"/>
           </a:solidFill>
-          <a:latin typeface="Arial"/>
+          <a:latin typeface="Atkinson Hyperlegible Next"/>
           <a:ea typeface="Arial"/>
           <a:cs typeface="Arial"/>
           <a:sym typeface="Arial"/>
@@ -17608,7 +17608,7 @@
           <a:solidFill>
             <a:srgbClr val="000000"/>
           </a:solidFill>
-          <a:latin typeface="Arial"/>
+          <a:latin typeface="Atkinson Hyperlegible Next"/>
           <a:ea typeface="Arial"/>
           <a:cs typeface="Arial"/>
           <a:sym typeface="Arial"/>
@@ -17645,7 +17645,7 @@
           <a:solidFill>
             <a:srgbClr val="000000"/>
           </a:solidFill>
-          <a:latin typeface="Arial"/>
+          <a:latin typeface="Atkinson Hyperlegible Next"/>
           <a:ea typeface="Arial"/>
           <a:cs typeface="Arial"/>
           <a:sym typeface="Arial"/>
@@ -17669,7 +17669,7 @@
           <a:solidFill>
             <a:srgbClr val="000000"/>
           </a:solidFill>
-          <a:latin typeface="Arial"/>
+          <a:latin typeface="Atkinson Hyperlegible Next"/>
           <a:ea typeface="Arial"/>
           <a:cs typeface="Arial"/>
           <a:sym typeface="Arial"/>
@@ -17693,7 +17693,7 @@
           <a:solidFill>
             <a:srgbClr val="000000"/>
           </a:solidFill>
-          <a:latin typeface="Arial"/>
+          <a:latin typeface="Atkinson Hyperlegible Next"/>
           <a:ea typeface="Arial"/>
           <a:cs typeface="Arial"/>
           <a:sym typeface="Arial"/>
@@ -17717,7 +17717,7 @@
           <a:solidFill>
             <a:srgbClr val="000000"/>
           </a:solidFill>
-          <a:latin typeface="Arial"/>
+          <a:latin typeface="Atkinson Hyperlegible Next"/>
           <a:ea typeface="Arial"/>
           <a:cs typeface="Arial"/>
           <a:sym typeface="Arial"/>
@@ -17741,7 +17741,7 @@
           <a:solidFill>
             <a:srgbClr val="000000"/>
           </a:solidFill>
-          <a:latin typeface="Arial"/>
+          <a:latin typeface="Atkinson Hyperlegible Next"/>
           <a:ea typeface="Arial"/>
           <a:cs typeface="Arial"/>
           <a:sym typeface="Arial"/>
@@ -17765,7 +17765,7 @@
           <a:solidFill>
             <a:srgbClr val="000000"/>
           </a:solidFill>
-          <a:latin typeface="Arial"/>
+          <a:latin typeface="Atkinson Hyperlegible Next"/>
           <a:ea typeface="Arial"/>
           <a:cs typeface="Arial"/>
           <a:sym typeface="Arial"/>
@@ -17789,7 +17789,7 @@
           <a:solidFill>
             <a:srgbClr val="000000"/>
           </a:solidFill>
-          <a:latin typeface="Arial"/>
+          <a:latin typeface="Atkinson Hyperlegible Next"/>
           <a:ea typeface="Arial"/>
           <a:cs typeface="Arial"/>
           <a:sym typeface="Arial"/>
@@ -17813,7 +17813,7 @@
           <a:solidFill>
             <a:srgbClr val="000000"/>
           </a:solidFill>
-          <a:latin typeface="Arial"/>
+          <a:latin typeface="Atkinson Hyperlegible Next"/>
           <a:ea typeface="Arial"/>
           <a:cs typeface="Arial"/>
           <a:sym typeface="Arial"/>
@@ -17837,7 +17837,7 @@
           <a:solidFill>
             <a:srgbClr val="000000"/>
           </a:solidFill>
-          <a:latin typeface="Arial"/>
+          <a:latin typeface="Atkinson Hyperlegible Next"/>
           <a:ea typeface="Arial"/>
           <a:cs typeface="Arial"/>
           <a:sym typeface="Arial"/>
@@ -17959,7 +17959,7 @@
               <a:solidFill>
                 <a:schemeClr val="lt1"/>
               </a:solidFill>
-              <a:latin typeface="Arial"/>
+              <a:latin typeface="Atkinson Hyperlegible Next"/>
               <a:ea typeface="Arial"/>
               <a:cs typeface="Arial"/>
               <a:sym typeface="Arial"/>
@@ -17983,7 +17983,7 @@
                 <a:solidFill>
                   <a:schemeClr val="lt1"/>
                 </a:solidFill>
-                <a:latin typeface="Arial"/>
+                <a:latin typeface="Atkinson Hyperlegible Next"/>
                 <a:ea typeface="Arial"/>
                 <a:cs typeface="Arial"/>
                 <a:sym typeface="Arial"/>
@@ -17994,7 +17994,7 @@
               <a:solidFill>
                 <a:srgbClr val="000000"/>
               </a:solidFill>
-              <a:latin typeface="Arial"/>
+              <a:latin typeface="Atkinson Hyperlegible Next"/>
               <a:ea typeface="Arial"/>
               <a:cs typeface="Arial"/>
               <a:sym typeface="Arial"/>
@@ -18049,7 +18049,7 @@
                 <a:solidFill>
                   <a:schemeClr val="lt1"/>
                 </a:solidFill>
-                <a:latin typeface="Arial"/>
+                <a:latin typeface="Atkinson Hyperlegible Next"/>
                 <a:ea typeface="Arial"/>
                 <a:cs typeface="Arial"/>
                 <a:sym typeface="Arial"/>
@@ -18061,7 +18061,7 @@
                 <a:solidFill>
                   <a:schemeClr val="lt1"/>
                 </a:solidFill>
-                <a:latin typeface="Arial"/>
+                <a:latin typeface="Atkinson Hyperlegible Next"/>
                 <a:ea typeface="Arial"/>
                 <a:cs typeface="Arial"/>
                 <a:sym typeface="Arial"/>
@@ -18073,7 +18073,7 @@
                 <a:solidFill>
                   <a:schemeClr val="lt1"/>
                 </a:solidFill>
-                <a:latin typeface="Arial"/>
+                <a:latin typeface="Atkinson Hyperlegible Next"/>
                 <a:ea typeface="Arial"/>
                 <a:cs typeface="Arial"/>
                 <a:sym typeface="Arial"/>
@@ -18085,7 +18085,7 @@
                 <a:solidFill>
                   <a:schemeClr val="lt1"/>
                 </a:solidFill>
-                <a:latin typeface="Arial"/>
+                <a:latin typeface="Atkinson Hyperlegible Next"/>
                 <a:ea typeface="Arial"/>
                 <a:cs typeface="Arial"/>
                 <a:sym typeface="Arial"/>
@@ -18096,7 +18096,7 @@
               <a:solidFill>
                 <a:schemeClr val="lt1"/>
               </a:solidFill>
-              <a:latin typeface="Arial"/>
+              <a:latin typeface="Atkinson Hyperlegible Next"/>
               <a:ea typeface="Arial"/>
               <a:cs typeface="Arial"/>
               <a:sym typeface="Arial"/>
@@ -18583,7 +18583,7 @@
               <a:solidFill>
                 <a:srgbClr val="13294B"/>
               </a:solidFill>
-              <a:latin typeface="Calibri"/>
+              <a:latin typeface="Atkinson Hyperlegible Next"/>
               <a:ea typeface="Calibri"/>
               <a:cs typeface="Calibri"/>
               <a:sym typeface="Calibri"/>
@@ -18644,7 +18644,7 @@
                 <a:solidFill>
                   <a:schemeClr val="lt1"/>
                 </a:solidFill>
-                <a:latin typeface="Arial"/>
+                <a:latin typeface="Atkinson Hyperlegible Next"/>
                 <a:ea typeface="Arial"/>
                 <a:cs typeface="Arial"/>
                 <a:sym typeface="Arial"/>
@@ -18655,7 +18655,7 @@
               <a:solidFill>
                 <a:schemeClr val="lt1"/>
               </a:solidFill>
-              <a:latin typeface="Arial"/>
+              <a:latin typeface="Atkinson Hyperlegible Next"/>
               <a:ea typeface="Arial"/>
               <a:cs typeface="Arial"/>
               <a:sym typeface="Arial"/>
@@ -18744,7 +18744,7 @@
                 <a:solidFill>
                   <a:srgbClr val="13294B"/>
                 </a:solidFill>
-                <a:latin typeface="Arial"/>
+                <a:latin typeface="Atkinson Hyperlegible Next"/>
                 <a:ea typeface="Arial"/>
                 <a:cs typeface="Arial"/>
                 <a:sym typeface="Arial"/>
@@ -18911,7 +18911,7 @@
                 <a:solidFill>
                   <a:srgbClr val="13294B"/>
                 </a:solidFill>
-                <a:latin typeface="Arial"/>
+                <a:latin typeface="Atkinson Hyperlegible Next"/>
                 <a:ea typeface="Arial"/>
                 <a:cs typeface="Arial"/>
                 <a:sym typeface="Arial"/>
@@ -19480,7 +19480,7 @@
               <a:solidFill>
                 <a:srgbClr val="13294B"/>
               </a:solidFill>
-              <a:latin typeface="Calibri"/>
+              <a:latin typeface="Atkinson Hyperlegible Next"/>
               <a:ea typeface="Calibri"/>
               <a:cs typeface="Calibri"/>
               <a:sym typeface="Calibri"/>
@@ -19541,7 +19541,7 @@
                 <a:solidFill>
                   <a:schemeClr val="lt1"/>
                 </a:solidFill>
-                <a:latin typeface="Arial"/>
+                <a:latin typeface="Atkinson Hyperlegible Next"/>
                 <a:ea typeface="Arial"/>
                 <a:cs typeface="Arial"/>
                 <a:sym typeface="Arial"/>
@@ -19552,7 +19552,7 @@
               <a:solidFill>
                 <a:schemeClr val="lt1"/>
               </a:solidFill>
-              <a:latin typeface="Arial"/>
+              <a:latin typeface="Atkinson Hyperlegible Next"/>
               <a:ea typeface="Arial"/>
               <a:cs typeface="Arial"/>
               <a:sym typeface="Arial"/>
@@ -19641,7 +19641,7 @@
                 <a:solidFill>
                   <a:srgbClr val="13294B"/>
                 </a:solidFill>
-                <a:latin typeface="Arial"/>
+                <a:latin typeface="Atkinson Hyperlegible Next"/>
                 <a:ea typeface="Arial"/>
                 <a:cs typeface="Arial"/>
                 <a:sym typeface="Arial"/>
@@ -19808,7 +19808,7 @@
                 <a:solidFill>
                   <a:srgbClr val="13294B"/>
                 </a:solidFill>
-                <a:latin typeface="Arial"/>
+                <a:latin typeface="Atkinson Hyperlegible Next"/>
                 <a:ea typeface="Arial"/>
                 <a:cs typeface="Arial"/>
                 <a:sym typeface="Arial"/>
@@ -20297,7 +20297,7 @@
               <a:solidFill>
                 <a:srgbClr val="13294B"/>
               </a:solidFill>
-              <a:latin typeface="Calibri"/>
+              <a:latin typeface="Atkinson Hyperlegible Next"/>
               <a:ea typeface="Calibri"/>
               <a:cs typeface="Calibri"/>
               <a:sym typeface="Calibri"/>
@@ -20358,7 +20358,7 @@
                 <a:solidFill>
                   <a:schemeClr val="lt1"/>
                 </a:solidFill>
-                <a:latin typeface="Arial"/>
+                <a:latin typeface="Atkinson Hyperlegible Next"/>
                 <a:ea typeface="Arial"/>
                 <a:cs typeface="Arial"/>
                 <a:sym typeface="Arial"/>
@@ -20369,7 +20369,7 @@
               <a:solidFill>
                 <a:schemeClr val="lt1"/>
               </a:solidFill>
-              <a:latin typeface="Arial"/>
+              <a:latin typeface="Atkinson Hyperlegible Next"/>
               <a:ea typeface="Arial"/>
               <a:cs typeface="Arial"/>
               <a:sym typeface="Arial"/>
@@ -20458,7 +20458,7 @@
                 <a:solidFill>
                   <a:srgbClr val="13294B"/>
                 </a:solidFill>
-                <a:latin typeface="Arial"/>
+                <a:latin typeface="Atkinson Hyperlegible Next"/>
                 <a:ea typeface="Arial"/>
                 <a:cs typeface="Arial"/>
                 <a:sym typeface="Arial"/>
@@ -20625,7 +20625,7 @@
                 <a:solidFill>
                   <a:srgbClr val="13294B"/>
                 </a:solidFill>
-                <a:latin typeface="Arial"/>
+                <a:latin typeface="Atkinson Hyperlegible Next"/>
                 <a:ea typeface="Arial"/>
                 <a:cs typeface="Arial"/>
                 <a:sym typeface="Arial"/>
@@ -21588,7 +21588,7 @@
               <a:solidFill>
                 <a:srgbClr val="13294B"/>
               </a:solidFill>
-              <a:latin typeface="Calibri"/>
+              <a:latin typeface="Atkinson Hyperlegible Next"/>
               <a:ea typeface="Calibri"/>
               <a:cs typeface="Calibri"/>
               <a:sym typeface="Calibri"/>
@@ -21649,7 +21649,7 @@
                 <a:solidFill>
                   <a:schemeClr val="lt1"/>
                 </a:solidFill>
-                <a:latin typeface="Arial"/>
+                <a:latin typeface="Atkinson Hyperlegible Next"/>
                 <a:ea typeface="Arial"/>
                 <a:cs typeface="Arial"/>
                 <a:sym typeface="Arial"/>
@@ -21660,7 +21660,7 @@
               <a:solidFill>
                 <a:schemeClr val="lt1"/>
               </a:solidFill>
-              <a:latin typeface="Arial"/>
+              <a:latin typeface="Atkinson Hyperlegible Next"/>
               <a:ea typeface="Arial"/>
               <a:cs typeface="Arial"/>
               <a:sym typeface="Arial"/>
@@ -21749,7 +21749,7 @@
                 <a:solidFill>
                   <a:srgbClr val="13294B"/>
                 </a:solidFill>
-                <a:latin typeface="Arial"/>
+                <a:latin typeface="Atkinson Hyperlegible Next"/>
                 <a:ea typeface="Arial"/>
                 <a:cs typeface="Arial"/>
                 <a:sym typeface="Arial"/>
@@ -21916,7 +21916,7 @@
                 <a:solidFill>
                   <a:srgbClr val="13294B"/>
                 </a:solidFill>
-                <a:latin typeface="Arial"/>
+                <a:latin typeface="Atkinson Hyperlegible Next"/>
                 <a:ea typeface="Arial"/>
                 <a:cs typeface="Arial"/>
                 <a:sym typeface="Arial"/>
@@ -22062,7 +22062,7 @@
                   <a:schemeClr val="tx1"/>
                 </a:solidFill>
                 <a:effectLst/>
-                <a:latin typeface="Arial" panose="020B0604020202020204" pitchFamily="34" charset="0"/>
+                <a:latin typeface="Atkinson Hyperlegible Next"/>
               </a:rPr>
               <a:t>A PMOS transistor pulls the pin </a:t>
             </a:r>
@@ -22075,7 +22075,7 @@
                   <a:schemeClr val="tx1"/>
                 </a:solidFill>
                 <a:effectLst/>
-                <a:latin typeface="Arial" panose="020B0604020202020204" pitchFamily="34" charset="0"/>
+                <a:latin typeface="Atkinson Hyperlegible Next"/>
               </a:rPr>
               <a:t>up</a:t>
             </a:r>
@@ -22088,7 +22088,7 @@
                   <a:schemeClr val="tx1"/>
                 </a:solidFill>
                 <a:effectLst/>
-                <a:latin typeface="Arial" panose="020B0604020202020204" pitchFamily="34" charset="0"/>
+                <a:latin typeface="Atkinson Hyperlegible Next"/>
               </a:rPr>
               <a:t> to 3.3 V</a:t>
             </a:r>
@@ -22118,7 +22118,7 @@
                 <a:schemeClr val="tx1"/>
               </a:solidFill>
               <a:effectLst/>
-              <a:latin typeface="Arial" panose="020B0604020202020204" pitchFamily="34" charset="0"/>
+              <a:latin typeface="Atkinson Hyperlegible Next"/>
             </a:endParaRPr>
           </a:p>
         </p:txBody>
@@ -22480,7 +22480,7 @@
               <a:solidFill>
                 <a:srgbClr val="13294B"/>
               </a:solidFill>
-              <a:latin typeface="Calibri"/>
+              <a:latin typeface="Atkinson Hyperlegible Next"/>
               <a:ea typeface="Calibri"/>
               <a:cs typeface="Calibri"/>
               <a:sym typeface="Calibri"/>
@@ -22541,7 +22541,7 @@
                 <a:solidFill>
                   <a:schemeClr val="lt1"/>
                 </a:solidFill>
-                <a:latin typeface="Arial"/>
+                <a:latin typeface="Atkinson Hyperlegible Next"/>
                 <a:ea typeface="Arial"/>
                 <a:cs typeface="Arial"/>
                 <a:sym typeface="Arial"/>
@@ -22552,7 +22552,7 @@
               <a:solidFill>
                 <a:schemeClr val="lt1"/>
               </a:solidFill>
-              <a:latin typeface="Arial"/>
+              <a:latin typeface="Atkinson Hyperlegible Next"/>
               <a:ea typeface="Arial"/>
               <a:cs typeface="Arial"/>
               <a:sym typeface="Arial"/>
@@ -22641,7 +22641,7 @@
                 <a:solidFill>
                   <a:srgbClr val="13294B"/>
                 </a:solidFill>
-                <a:latin typeface="Arial"/>
+                <a:latin typeface="Atkinson Hyperlegible Next"/>
                 <a:ea typeface="Arial"/>
                 <a:cs typeface="Arial"/>
                 <a:sym typeface="Arial"/>
@@ -22808,7 +22808,7 @@
                 <a:solidFill>
                   <a:srgbClr val="13294B"/>
                 </a:solidFill>
-                <a:latin typeface="Arial"/>
+                <a:latin typeface="Atkinson Hyperlegible Next"/>
                 <a:ea typeface="Arial"/>
                 <a:cs typeface="Arial"/>
                 <a:sym typeface="Arial"/>
@@ -22954,7 +22954,7 @@
                   <a:schemeClr val="tx1"/>
                 </a:solidFill>
                 <a:effectLst/>
-                <a:latin typeface="Arial" panose="020B0604020202020204" pitchFamily="34" charset="0"/>
+                <a:latin typeface="Atkinson Hyperlegible Next"/>
               </a:rPr>
               <a:t>A PMOS transistor pulls the pin </a:t>
             </a:r>
@@ -22967,7 +22967,7 @@
                   <a:schemeClr val="tx1"/>
                 </a:solidFill>
                 <a:effectLst/>
-                <a:latin typeface="Arial" panose="020B0604020202020204" pitchFamily="34" charset="0"/>
+                <a:latin typeface="Atkinson Hyperlegible Next"/>
               </a:rPr>
               <a:t>up</a:t>
             </a:r>
@@ -22980,7 +22980,7 @@
                   <a:schemeClr val="tx1"/>
                 </a:solidFill>
                 <a:effectLst/>
-                <a:latin typeface="Arial" panose="020B0604020202020204" pitchFamily="34" charset="0"/>
+                <a:latin typeface="Atkinson Hyperlegible Next"/>
               </a:rPr>
               <a:t> to 3.3 V</a:t>
             </a:r>
@@ -23010,7 +23010,7 @@
                 <a:schemeClr val="tx1"/>
               </a:solidFill>
               <a:effectLst/>
-              <a:latin typeface="Arial" panose="020B0604020202020204" pitchFamily="34" charset="0"/>
+              <a:latin typeface="Atkinson Hyperlegible Next"/>
             </a:endParaRPr>
           </a:p>
         </p:txBody>
@@ -23780,7 +23780,7 @@
               <a:solidFill>
                 <a:srgbClr val="13294B"/>
               </a:solidFill>
-              <a:latin typeface="Calibri"/>
+              <a:latin typeface="Atkinson Hyperlegible Next"/>
               <a:ea typeface="Calibri"/>
               <a:cs typeface="Calibri"/>
               <a:sym typeface="Calibri"/>
@@ -23841,7 +23841,7 @@
                 <a:solidFill>
                   <a:schemeClr val="lt1"/>
                 </a:solidFill>
-                <a:latin typeface="Arial"/>
+                <a:latin typeface="Atkinson Hyperlegible Next"/>
                 <a:ea typeface="Arial"/>
                 <a:cs typeface="Arial"/>
                 <a:sym typeface="Arial"/>
@@ -23852,7 +23852,7 @@
               <a:solidFill>
                 <a:schemeClr val="lt1"/>
               </a:solidFill>
-              <a:latin typeface="Arial"/>
+              <a:latin typeface="Atkinson Hyperlegible Next"/>
               <a:ea typeface="Arial"/>
               <a:cs typeface="Arial"/>
               <a:sym typeface="Arial"/>
@@ -23941,7 +23941,7 @@
                 <a:solidFill>
                   <a:srgbClr val="13294B"/>
                 </a:solidFill>
-                <a:latin typeface="Arial"/>
+                <a:latin typeface="Atkinson Hyperlegible Next"/>
                 <a:ea typeface="Arial"/>
                 <a:cs typeface="Arial"/>
                 <a:sym typeface="Arial"/>
@@ -24108,7 +24108,7 @@
                 <a:solidFill>
                   <a:srgbClr val="13294B"/>
                 </a:solidFill>
-                <a:latin typeface="Arial"/>
+                <a:latin typeface="Atkinson Hyperlegible Next"/>
                 <a:ea typeface="Arial"/>
                 <a:cs typeface="Arial"/>
                 <a:sym typeface="Arial"/>
@@ -24483,7 +24483,7 @@
               <a:solidFill>
                 <a:srgbClr val="13294B"/>
               </a:solidFill>
-              <a:latin typeface="Calibri"/>
+              <a:latin typeface="Atkinson Hyperlegible Next"/>
               <a:ea typeface="Calibri"/>
               <a:cs typeface="Calibri"/>
               <a:sym typeface="Calibri"/>
@@ -24544,7 +24544,7 @@
                 <a:solidFill>
                   <a:schemeClr val="lt1"/>
                 </a:solidFill>
-                <a:latin typeface="Arial"/>
+                <a:latin typeface="Atkinson Hyperlegible Next"/>
                 <a:ea typeface="Arial"/>
                 <a:cs typeface="Arial"/>
                 <a:sym typeface="Arial"/>
@@ -24555,7 +24555,7 @@
               <a:solidFill>
                 <a:schemeClr val="lt1"/>
               </a:solidFill>
-              <a:latin typeface="Arial"/>
+              <a:latin typeface="Atkinson Hyperlegible Next"/>
               <a:ea typeface="Arial"/>
               <a:cs typeface="Arial"/>
               <a:sym typeface="Arial"/>
@@ -24644,7 +24644,7 @@
                 <a:solidFill>
                   <a:srgbClr val="13294B"/>
                 </a:solidFill>
-                <a:latin typeface="Arial"/>
+                <a:latin typeface="Atkinson Hyperlegible Next"/>
                 <a:ea typeface="Arial"/>
                 <a:cs typeface="Arial"/>
                 <a:sym typeface="Arial"/>
@@ -24811,7 +24811,7 @@
                 <a:solidFill>
                   <a:srgbClr val="13294B"/>
                 </a:solidFill>
-                <a:latin typeface="Arial"/>
+                <a:latin typeface="Atkinson Hyperlegible Next"/>
                 <a:ea typeface="Arial"/>
                 <a:cs typeface="Arial"/>
                 <a:sym typeface="Arial"/>
@@ -25000,7 +25000,7 @@
                 <a:solidFill>
                   <a:srgbClr val="15264B"/>
                 </a:solidFill>
-                <a:latin typeface="Arial"/>
+                <a:latin typeface="Atkinson Hyperlegible Next"/>
                 <a:ea typeface="Arial"/>
                 <a:cs typeface="Arial"/>
                 <a:sym typeface="Arial"/>
@@ -25177,7 +25177,7 @@
                 <a:solidFill>
                   <a:srgbClr val="13294B"/>
                 </a:solidFill>
-                <a:latin typeface="Arial"/>
+                <a:latin typeface="Atkinson Hyperlegible Next"/>
                 <a:ea typeface="Arial"/>
                 <a:cs typeface="Arial"/>
                 <a:sym typeface="Arial"/>
@@ -25344,7 +25344,7 @@
                 <a:solidFill>
                   <a:srgbClr val="13294B"/>
                 </a:solidFill>
-                <a:latin typeface="Arial"/>
+                <a:latin typeface="Atkinson Hyperlegible Next"/>
                 <a:ea typeface="Arial"/>
                 <a:cs typeface="Arial"/>
                 <a:sym typeface="Arial"/>
@@ -25439,7 +25439,7 @@
             </a:pPr>
             <a:r>
               <a:rPr lang="en-US" sz="1800" dirty="0">
-                <a:latin typeface="Arial"/>
+                <a:latin typeface="Atkinson Hyperlegible Next"/>
                 <a:ea typeface="Arial"/>
                 <a:cs typeface="Arial"/>
                 <a:sym typeface="Arial"/>
@@ -25448,7 +25448,7 @@
             </a:r>
             <a:r>
               <a:rPr lang="en-US" sz="1800" b="1" dirty="0">
-                <a:latin typeface="Arial"/>
+                <a:latin typeface="Atkinson Hyperlegible Next"/>
                 <a:ea typeface="Arial"/>
                 <a:cs typeface="Arial"/>
                 <a:sym typeface="Arial"/>
@@ -25457,7 +25457,7 @@
             </a:r>
             <a:r>
               <a:rPr lang="en-US" sz="1800" dirty="0">
-                <a:latin typeface="Arial"/>
+                <a:latin typeface="Atkinson Hyperlegible Next"/>
                 <a:ea typeface="Arial"/>
                 <a:cs typeface="Arial"/>
                 <a:sym typeface="Arial"/>
@@ -25466,7 +25466,7 @@
             </a:r>
             <a:r>
               <a:rPr lang="en-US" sz="1800" b="1" dirty="0">
-                <a:latin typeface="Arial"/>
+                <a:latin typeface="Atkinson Hyperlegible Next"/>
                 <a:ea typeface="Arial"/>
                 <a:cs typeface="Arial"/>
                 <a:sym typeface="Arial"/>
@@ -25475,7 +25475,7 @@
             </a:r>
             <a:r>
               <a:rPr lang="en-US" sz="1800" dirty="0">
-                <a:latin typeface="Arial"/>
+                <a:latin typeface="Atkinson Hyperlegible Next"/>
                 <a:ea typeface="Arial"/>
                 <a:cs typeface="Arial"/>
                 <a:sym typeface="Arial"/>
@@ -25495,7 +25495,7 @@
               <a:buNone/>
             </a:pPr>
             <a:endParaRPr lang="en-US" sz="1800" dirty="0">
-              <a:latin typeface="Arial"/>
+              <a:latin typeface="Atkinson Hyperlegible Next"/>
               <a:ea typeface="Arial"/>
               <a:cs typeface="Arial"/>
               <a:sym typeface="Arial"/>
@@ -25514,7 +25514,7 @@
             </a:pPr>
             <a:r>
               <a:rPr lang="en-US" sz="1800" dirty="0">
-                <a:latin typeface="Arial"/>
+                <a:latin typeface="Atkinson Hyperlegible Next"/>
                 <a:ea typeface="Arial"/>
                 <a:cs typeface="Arial"/>
                 <a:sym typeface="Arial"/>
@@ -25534,7 +25534,7 @@
             </a:pPr>
             <a:r>
               <a:rPr lang="en-US" sz="1800" dirty="0">
-                <a:latin typeface="Arial"/>
+                <a:latin typeface="Atkinson Hyperlegible Next"/>
                 <a:ea typeface="Arial"/>
                 <a:cs typeface="Arial"/>
                 <a:sym typeface="Arial"/>
@@ -25554,7 +25554,7 @@
             </a:pPr>
             <a:r>
               <a:rPr lang="en-US" sz="1800" dirty="0">
-                <a:latin typeface="Arial"/>
+                <a:latin typeface="Atkinson Hyperlegible Next"/>
                 <a:ea typeface="Arial"/>
                 <a:cs typeface="Arial"/>
                 <a:sym typeface="Arial"/>
@@ -25574,7 +25574,7 @@
             </a:pPr>
             <a:r>
               <a:rPr lang="en-US" sz="1800" dirty="0">
-                <a:latin typeface="Arial"/>
+                <a:latin typeface="Atkinson Hyperlegible Next"/>
                 <a:ea typeface="Arial"/>
                 <a:cs typeface="Arial"/>
                 <a:sym typeface="Arial"/>
@@ -25594,7 +25594,7 @@
             </a:pPr>
             <a:r>
               <a:rPr lang="en-US" sz="1800" dirty="0">
-                <a:latin typeface="Arial"/>
+                <a:latin typeface="Atkinson Hyperlegible Next"/>
                 <a:ea typeface="Arial"/>
                 <a:cs typeface="Arial"/>
                 <a:sym typeface="Arial"/>
@@ -25614,7 +25614,7 @@
             </a:pPr>
             <a:r>
               <a:rPr lang="en-US" sz="1800" dirty="0">
-                <a:latin typeface="Arial"/>
+                <a:latin typeface="Atkinson Hyperlegible Next"/>
                 <a:ea typeface="Arial"/>
                 <a:cs typeface="Arial"/>
                 <a:sym typeface="Arial"/>
@@ -25634,7 +25634,7 @@
             </a:pPr>
             <a:r>
               <a:rPr lang="en-US" sz="1800" dirty="0">
-                <a:latin typeface="Arial"/>
+                <a:latin typeface="Atkinson Hyperlegible Next"/>
                 <a:ea typeface="Arial"/>
                 <a:cs typeface="Arial"/>
                 <a:sym typeface="Arial"/>
@@ -25654,7 +25654,7 @@
             </a:pPr>
             <a:r>
               <a:rPr lang="en-US" sz="1800" dirty="0">
-                <a:latin typeface="Arial"/>
+                <a:latin typeface="Atkinson Hyperlegible Next"/>
                 <a:ea typeface="Arial"/>
                 <a:cs typeface="Arial"/>
                 <a:sym typeface="Arial"/>
@@ -25673,7 +25673,7 @@
               <a:buSzPts val="3000"/>
             </a:pPr>
             <a:endParaRPr lang="en-US" sz="1800" dirty="0">
-              <a:latin typeface="Arial"/>
+              <a:latin typeface="Atkinson Hyperlegible Next"/>
               <a:ea typeface="Arial"/>
               <a:cs typeface="Arial"/>
               <a:sym typeface="Arial"/>
@@ -25692,7 +25692,7 @@
             </a:pPr>
             <a:r>
               <a:rPr lang="en-US" sz="1800" dirty="0">
-                <a:latin typeface="Arial"/>
+                <a:latin typeface="Atkinson Hyperlegible Next"/>
                 <a:ea typeface="Arial"/>
                 <a:cs typeface="Arial"/>
                 <a:sym typeface="Arial"/>
@@ -25701,7 +25701,7 @@
             </a:r>
             <a:r>
               <a:rPr lang="en-US" sz="1800" dirty="0">
-                <a:latin typeface="Arial"/>
+                <a:latin typeface="Atkinson Hyperlegible Next"/>
                 <a:ea typeface="Arial"/>
                 <a:cs typeface="Arial"/>
                 <a:sym typeface="Arial"/>
@@ -25711,7 +25711,7 @@
             </a:r>
             <a:r>
               <a:rPr lang="en-US" sz="1800" dirty="0">
-                <a:latin typeface="Arial"/>
+                <a:latin typeface="Atkinson Hyperlegible Next"/>
                 <a:ea typeface="Arial"/>
                 <a:cs typeface="Arial"/>
                 <a:sym typeface="Arial"/>
@@ -25731,7 +25731,7 @@
               <a:buNone/>
             </a:pPr>
             <a:endParaRPr lang="en-US" sz="1800" dirty="0">
-              <a:latin typeface="Arial"/>
+              <a:latin typeface="Atkinson Hyperlegible Next"/>
               <a:ea typeface="Arial"/>
               <a:cs typeface="Arial"/>
               <a:sym typeface="Arial"/>
@@ -25750,7 +25750,7 @@
             </a:pPr>
             <a:r>
               <a:rPr lang="en-US" sz="1800" dirty="0">
-                <a:latin typeface="Arial"/>
+                <a:latin typeface="Atkinson Hyperlegible Next"/>
                 <a:ea typeface="Arial"/>
                 <a:cs typeface="Arial"/>
                 <a:sym typeface="Arial"/>
@@ -25759,7 +25759,7 @@
             </a:r>
             <a:r>
               <a:rPr lang="en-US" sz="1800" b="1" dirty="0">
-                <a:latin typeface="Arial"/>
+                <a:latin typeface="Atkinson Hyperlegible Next"/>
                 <a:ea typeface="Arial"/>
                 <a:cs typeface="Arial"/>
                 <a:sym typeface="Arial"/>
@@ -25768,7 +25768,7 @@
             </a:r>
             <a:r>
               <a:rPr lang="en-US" sz="1800" dirty="0">
-                <a:latin typeface="Arial"/>
+                <a:latin typeface="Atkinson Hyperlegible Next"/>
                 <a:ea typeface="Arial"/>
                 <a:cs typeface="Arial"/>
                 <a:sym typeface="Arial"/>
@@ -25788,7 +25788,7 @@
               <a:buNone/>
             </a:pPr>
             <a:endParaRPr lang="en-US" sz="1800" dirty="0">
-              <a:latin typeface="Arial"/>
+              <a:latin typeface="Atkinson Hyperlegible Next"/>
               <a:ea typeface="Arial"/>
               <a:cs typeface="Arial"/>
               <a:sym typeface="Arial"/>
@@ -25807,7 +25807,7 @@
             </a:pPr>
             <a:r>
               <a:rPr lang="en-US" sz="1800" dirty="0">
-                <a:latin typeface="Arial"/>
+                <a:latin typeface="Atkinson Hyperlegible Next"/>
                 <a:ea typeface="Arial"/>
                 <a:cs typeface="Arial"/>
                 <a:sym typeface="Arial"/>
@@ -25830,7 +25830,7 @@
               <a:buNone/>
             </a:pPr>
             <a:endParaRPr lang="en-US" sz="1800" dirty="0">
-              <a:latin typeface="Arial"/>
+              <a:latin typeface="Atkinson Hyperlegible Next"/>
               <a:ea typeface="Arial"/>
               <a:cs typeface="Arial"/>
               <a:sym typeface="Arial"/>
@@ -25892,7 +25892,7 @@
               <a:solidFill>
                 <a:srgbClr val="13294B"/>
               </a:solidFill>
-              <a:latin typeface="Calibri"/>
+              <a:latin typeface="Atkinson Hyperlegible Next"/>
               <a:ea typeface="Calibri"/>
               <a:cs typeface="Calibri"/>
               <a:sym typeface="Calibri"/>
@@ -25953,7 +25953,7 @@
                 <a:solidFill>
                   <a:schemeClr val="lt1"/>
                 </a:solidFill>
-                <a:latin typeface="Arial"/>
+                <a:latin typeface="Atkinson Hyperlegible Next"/>
                 <a:ea typeface="Arial"/>
                 <a:cs typeface="Arial"/>
                 <a:sym typeface="Arial"/>
@@ -25964,7 +25964,7 @@
               <a:solidFill>
                 <a:schemeClr val="lt1"/>
               </a:solidFill>
-              <a:latin typeface="Arial"/>
+              <a:latin typeface="Atkinson Hyperlegible Next"/>
               <a:ea typeface="Arial"/>
               <a:cs typeface="Arial"/>
               <a:sym typeface="Arial"/>
@@ -26053,7 +26053,7 @@
                 <a:solidFill>
                   <a:srgbClr val="13294B"/>
                 </a:solidFill>
-                <a:latin typeface="Arial"/>
+                <a:latin typeface="Atkinson Hyperlegible Next"/>
                 <a:ea typeface="Arial"/>
                 <a:cs typeface="Arial"/>
                 <a:sym typeface="Arial"/>
@@ -26220,7 +26220,7 @@
                 <a:solidFill>
                   <a:srgbClr val="13294B"/>
                 </a:solidFill>
-                <a:latin typeface="Arial"/>
+                <a:latin typeface="Atkinson Hyperlegible Next"/>
                 <a:ea typeface="Arial"/>
                 <a:cs typeface="Arial"/>
                 <a:sym typeface="Arial"/>
@@ -26315,7 +26315,7 @@
             </a:pPr>
             <a:r>
               <a:rPr lang="en-US" sz="1800" dirty="0">
-                <a:latin typeface="Arial"/>
+                <a:latin typeface="Atkinson Hyperlegible Next"/>
                 <a:ea typeface="Arial"/>
                 <a:cs typeface="Arial"/>
                 <a:sym typeface="Arial"/>
@@ -26379,7 +26379,7 @@
               <a:solidFill>
                 <a:srgbClr val="13294B"/>
               </a:solidFill>
-              <a:latin typeface="Calibri"/>
+              <a:latin typeface="Atkinson Hyperlegible Next"/>
               <a:ea typeface="Calibri"/>
               <a:cs typeface="Calibri"/>
               <a:sym typeface="Calibri"/>
@@ -26440,7 +26440,7 @@
                 <a:solidFill>
                   <a:schemeClr val="lt1"/>
                 </a:solidFill>
-                <a:latin typeface="Arial"/>
+                <a:latin typeface="Atkinson Hyperlegible Next"/>
                 <a:ea typeface="Arial"/>
                 <a:cs typeface="Arial"/>
                 <a:sym typeface="Arial"/>
@@ -26452,7 +26452,7 @@
                 <a:solidFill>
                   <a:schemeClr val="lt1"/>
                 </a:solidFill>
-                <a:latin typeface="Arial"/>
+                <a:latin typeface="Atkinson Hyperlegible Next"/>
                 <a:ea typeface="Arial"/>
                 <a:cs typeface="Arial"/>
                 <a:sym typeface="Arial"/>
@@ -26464,7 +26464,7 @@
                 <a:solidFill>
                   <a:schemeClr val="lt1"/>
                 </a:solidFill>
-                <a:latin typeface="Arial"/>
+                <a:latin typeface="Atkinson Hyperlegible Next"/>
                 <a:ea typeface="Arial"/>
                 <a:cs typeface="Arial"/>
                 <a:sym typeface="Arial"/>
@@ -26555,7 +26555,7 @@
                 <a:solidFill>
                   <a:srgbClr val="13294B"/>
                 </a:solidFill>
-                <a:latin typeface="Arial"/>
+                <a:latin typeface="Atkinson Hyperlegible Next"/>
                 <a:ea typeface="Arial"/>
                 <a:cs typeface="Arial"/>
                 <a:sym typeface="Arial"/>
@@ -26722,7 +26722,7 @@
                 <a:solidFill>
                   <a:srgbClr val="13294B"/>
                 </a:solidFill>
-                <a:latin typeface="Arial"/>
+                <a:latin typeface="Atkinson Hyperlegible Next"/>
                 <a:ea typeface="Arial"/>
                 <a:cs typeface="Arial"/>
                 <a:sym typeface="Arial"/>
@@ -26956,7 +26956,7 @@
                 <a:solidFill>
                   <a:srgbClr val="E84B36"/>
                 </a:solidFill>
-                <a:latin typeface="Arial"/>
+                <a:latin typeface="Atkinson Hyperlegible Next"/>
                 <a:ea typeface="Arial"/>
                 <a:cs typeface="Arial"/>
                 <a:sym typeface="Arial"/>
@@ -26967,7 +26967,7 @@
               <a:solidFill>
                 <a:srgbClr val="E84B36"/>
               </a:solidFill>
-              <a:latin typeface="Arial"/>
+              <a:latin typeface="Atkinson Hyperlegible Next"/>
               <a:ea typeface="Arial"/>
               <a:cs typeface="Arial"/>
               <a:sym typeface="Arial"/>
@@ -26988,7 +26988,7 @@
                 <a:solidFill>
                   <a:schemeClr val="dk1"/>
                 </a:solidFill>
-                <a:latin typeface="Arial"/>
+                <a:latin typeface="Atkinson Hyperlegible Next"/>
                 <a:ea typeface="Arial"/>
                 <a:cs typeface="Arial"/>
                 <a:sym typeface="Arial"/>
@@ -27000,7 +27000,7 @@
                 <a:solidFill>
                   <a:schemeClr val="dk1"/>
                 </a:solidFill>
-                <a:latin typeface="Arial"/>
+                <a:latin typeface="Atkinson Hyperlegible Next"/>
                 <a:ea typeface="Arial"/>
                 <a:cs typeface="Arial"/>
                 <a:sym typeface="Arial"/>
@@ -27012,7 +27012,7 @@
                 <a:solidFill>
                   <a:schemeClr val="dk1"/>
                 </a:solidFill>
-                <a:latin typeface="Arial"/>
+                <a:latin typeface="Atkinson Hyperlegible Next"/>
                 <a:ea typeface="Arial"/>
                 <a:cs typeface="Arial"/>
                 <a:sym typeface="Arial"/>
@@ -27024,7 +27024,7 @@
                 <a:solidFill>
                   <a:schemeClr val="dk1"/>
                 </a:solidFill>
-                <a:latin typeface="Arial"/>
+                <a:latin typeface="Atkinson Hyperlegible Next"/>
                 <a:ea typeface="Arial"/>
                 <a:cs typeface="Arial"/>
                 <a:sym typeface="Arial"/>
@@ -27044,7 +27044,7 @@
             </a:pPr>
             <a:r>
               <a:rPr lang="en-US" sz="1800" b="1" dirty="0">
-                <a:latin typeface="Arial"/>
+                <a:latin typeface="Atkinson Hyperlegible Next"/>
                 <a:ea typeface="Arial"/>
                 <a:cs typeface="Arial"/>
                 <a:sym typeface="Arial"/>
@@ -27053,7 +27053,7 @@
             </a:r>
             <a:r>
               <a:rPr lang="en-US" sz="1800" dirty="0">
-                <a:latin typeface="Arial"/>
+                <a:latin typeface="Atkinson Hyperlegible Next"/>
                 <a:ea typeface="Arial"/>
                 <a:cs typeface="Arial"/>
                 <a:sym typeface="Arial"/>
@@ -27062,7 +27062,7 @@
             </a:r>
             <a:r>
               <a:rPr lang="en-US" sz="1800" b="1" dirty="0">
-                <a:latin typeface="Arial"/>
+                <a:latin typeface="Atkinson Hyperlegible Next"/>
                 <a:ea typeface="Arial"/>
                 <a:cs typeface="Arial"/>
                 <a:sym typeface="Arial"/>
@@ -27071,7 +27071,7 @@
             </a:r>
             <a:r>
               <a:rPr lang="en-US" sz="1800" dirty="0">
-                <a:latin typeface="Arial"/>
+                <a:latin typeface="Atkinson Hyperlegible Next"/>
                 <a:ea typeface="Arial"/>
                 <a:cs typeface="Arial"/>
                 <a:sym typeface="Arial"/>
@@ -27094,7 +27094,7 @@
                 <a:solidFill>
                   <a:schemeClr val="dk1"/>
                 </a:solidFill>
-                <a:latin typeface="Arial"/>
+                <a:latin typeface="Atkinson Hyperlegible Next"/>
                 <a:ea typeface="Arial"/>
                 <a:cs typeface="Arial"/>
                 <a:sym typeface="Arial"/>
@@ -27103,7 +27103,7 @@
             </a:r>
             <a:r>
               <a:rPr lang="en-US" sz="1800" dirty="0">
-                <a:latin typeface="Arial"/>
+                <a:latin typeface="Atkinson Hyperlegible Next"/>
                 <a:ea typeface="Arial"/>
                 <a:cs typeface="Arial"/>
                 <a:sym typeface="Arial"/>
@@ -27112,7 +27112,7 @@
             </a:r>
             <a:r>
               <a:rPr lang="en-US" sz="1800" b="1" dirty="0">
-                <a:latin typeface="Arial"/>
+                <a:latin typeface="Atkinson Hyperlegible Next"/>
                 <a:ea typeface="Arial"/>
                 <a:cs typeface="Arial"/>
                 <a:sym typeface="Arial"/>
@@ -27121,7 +27121,7 @@
             </a:r>
             <a:r>
               <a:rPr lang="en-US" sz="1800" dirty="0">
-                <a:latin typeface="Arial"/>
+                <a:latin typeface="Atkinson Hyperlegible Next"/>
                 <a:ea typeface="Arial"/>
                 <a:cs typeface="Arial"/>
                 <a:sym typeface="Arial"/>
@@ -27144,7 +27144,7 @@
                 <a:solidFill>
                   <a:schemeClr val="dk1"/>
                 </a:solidFill>
-                <a:latin typeface="Arial"/>
+                <a:latin typeface="Atkinson Hyperlegible Next"/>
                 <a:ea typeface="Arial"/>
                 <a:cs typeface="Arial"/>
                 <a:sym typeface="Arial"/>
@@ -27156,7 +27156,7 @@
                 <a:solidFill>
                   <a:schemeClr val="dk1"/>
                 </a:solidFill>
-                <a:latin typeface="Arial"/>
+                <a:latin typeface="Atkinson Hyperlegible Next"/>
                 <a:ea typeface="Arial"/>
                 <a:cs typeface="Arial"/>
                 <a:sym typeface="Arial"/>
@@ -27168,7 +27168,7 @@
                 <a:solidFill>
                   <a:schemeClr val="dk1"/>
                 </a:solidFill>
-                <a:latin typeface="Arial"/>
+                <a:latin typeface="Atkinson Hyperlegible Next"/>
                 <a:ea typeface="Arial"/>
                 <a:cs typeface="Arial"/>
                 <a:sym typeface="Arial"/>
@@ -27180,7 +27180,7 @@
                 <a:solidFill>
                   <a:schemeClr val="dk1"/>
                 </a:solidFill>
-                <a:latin typeface="Arial"/>
+                <a:latin typeface="Atkinson Hyperlegible Next"/>
                 <a:ea typeface="Arial"/>
                 <a:cs typeface="Arial"/>
                 <a:sym typeface="Arial"/>
@@ -27199,7 +27199,7 @@
               <a:buSzPts val="3000"/>
             </a:pPr>
             <a:endParaRPr lang="en-US" sz="1800" b="1" dirty="0">
-              <a:latin typeface="Arial"/>
+              <a:latin typeface="Atkinson Hyperlegible Next"/>
               <a:ea typeface="Arial"/>
               <a:cs typeface="Arial"/>
               <a:sym typeface="Arial"/>
@@ -27221,7 +27221,7 @@
                 <a:solidFill>
                   <a:srgbClr val="E84B36"/>
                 </a:solidFill>
-                <a:latin typeface="Arial"/>
+                <a:latin typeface="Atkinson Hyperlegible Next"/>
                 <a:ea typeface="Arial"/>
                 <a:cs typeface="Arial"/>
                 <a:sym typeface="Arial"/>
@@ -27230,7 +27230,7 @@
             </a:r>
             <a:r>
               <a:rPr lang="en-US" sz="1800" dirty="0">
-                <a:latin typeface="Arial"/>
+                <a:latin typeface="Atkinson Hyperlegible Next"/>
                 <a:ea typeface="Arial"/>
                 <a:cs typeface="Arial"/>
                 <a:sym typeface="Arial"/>
@@ -27239,7 +27239,7 @@
             </a:r>
             <a:r>
               <a:rPr lang="en-US" sz="1800" dirty="0">
-                <a:latin typeface="Arial"/>
+                <a:latin typeface="Atkinson Hyperlegible Next"/>
                 <a:ea typeface="Arial"/>
                 <a:cs typeface="Arial"/>
                 <a:sym typeface="Arial"/>
@@ -27249,7 +27249,7 @@
             </a:r>
             <a:r>
               <a:rPr lang="en-US" sz="1800" dirty="0">
-                <a:latin typeface="Arial"/>
+                <a:latin typeface="Atkinson Hyperlegible Next"/>
                 <a:ea typeface="Arial"/>
                 <a:cs typeface="Arial"/>
                 <a:sym typeface="Arial"/>
@@ -27260,7 +27260,7 @@
               <a:solidFill>
                 <a:srgbClr val="E84B36"/>
               </a:solidFill>
-              <a:latin typeface="Arial"/>
+              <a:latin typeface="Atkinson Hyperlegible Next"/>
               <a:ea typeface="Arial"/>
               <a:cs typeface="Arial"/>
               <a:sym typeface="Arial"/>
@@ -27281,7 +27281,7 @@
               <a:solidFill>
                 <a:srgbClr val="E84B36"/>
               </a:solidFill>
-              <a:latin typeface="Arial"/>
+              <a:latin typeface="Atkinson Hyperlegible Next"/>
               <a:ea typeface="Arial"/>
               <a:cs typeface="Arial"/>
               <a:sym typeface="Arial"/>
@@ -27303,7 +27303,7 @@
                 <a:solidFill>
                   <a:srgbClr val="E84B36"/>
                 </a:solidFill>
-                <a:latin typeface="Arial"/>
+                <a:latin typeface="Atkinson Hyperlegible Next"/>
                 <a:ea typeface="Arial"/>
                 <a:cs typeface="Arial"/>
                 <a:sym typeface="Arial"/>
@@ -27315,7 +27315,7 @@
                 <a:solidFill>
                   <a:srgbClr val="E84B36"/>
                 </a:solidFill>
-                <a:latin typeface="Arial"/>
+                <a:latin typeface="Atkinson Hyperlegible Next"/>
                 <a:ea typeface="Arial"/>
                 <a:cs typeface="Arial"/>
                 <a:sym typeface="Arial"/>
@@ -27335,7 +27335,7 @@
             </a:pPr>
             <a:r>
               <a:rPr lang="en-US" sz="1800" dirty="0">
-                <a:latin typeface="Arial"/>
+                <a:latin typeface="Atkinson Hyperlegible Next"/>
                 <a:ea typeface="Arial"/>
                 <a:cs typeface="Arial"/>
                 <a:sym typeface="Arial"/>
@@ -27344,7 +27344,7 @@
             </a:r>
             <a:r>
               <a:rPr lang="en-US" sz="1800" dirty="0">
-                <a:latin typeface="Arial"/>
+                <a:latin typeface="Atkinson Hyperlegible Next"/>
                 <a:ea typeface="Arial"/>
                 <a:cs typeface="Arial"/>
                 <a:sym typeface="Arial"/>
@@ -27354,7 +27354,7 @@
             </a:r>
             <a:r>
               <a:rPr lang="en-US" sz="1800" dirty="0">
-                <a:latin typeface="Arial"/>
+                <a:latin typeface="Atkinson Hyperlegible Next"/>
                 <a:ea typeface="Arial"/>
                 <a:cs typeface="Arial"/>
                 <a:sym typeface="Arial"/>
@@ -27363,7 +27363,7 @@
             </a:r>
             <a:r>
               <a:rPr lang="en-US" sz="1800" b="1" dirty="0">
-                <a:latin typeface="Arial"/>
+                <a:latin typeface="Atkinson Hyperlegible Next"/>
                 <a:ea typeface="Arial"/>
                 <a:cs typeface="Arial"/>
                 <a:sym typeface="Arial"/>
@@ -27371,7 +27371,7 @@
               <a:t>February 3, 5PM</a:t>
             </a:r>
             <a:endParaRPr lang="en-US" sz="1400" b="1" dirty="0">
-              <a:latin typeface="Arial"/>
+              <a:latin typeface="Atkinson Hyperlegible Next"/>
               <a:ea typeface="Arial"/>
               <a:cs typeface="Arial"/>
               <a:sym typeface="Arial"/>
@@ -27389,7 +27389,7 @@
             </a:pPr>
             <a:r>
               <a:rPr lang="en-US" sz="1800" dirty="0">
-                <a:latin typeface="Arial"/>
+                <a:latin typeface="Atkinson Hyperlegible Next"/>
                 <a:ea typeface="Arial"/>
                 <a:cs typeface="Arial"/>
                 <a:sym typeface="Arial"/>
@@ -27398,7 +27398,7 @@
             </a:r>
             <a:r>
               <a:rPr lang="en-US" sz="1800" b="1" dirty="0">
-                <a:latin typeface="Arial"/>
+                <a:latin typeface="Atkinson Hyperlegible Next"/>
                 <a:ea typeface="Arial"/>
                 <a:cs typeface="Arial"/>
                 <a:sym typeface="Arial"/>
@@ -27417,7 +27417,7 @@
               <a:buSzPts val="3000"/>
             </a:pPr>
             <a:endParaRPr lang="en-US" sz="1800" dirty="0">
-              <a:latin typeface="Arial"/>
+              <a:latin typeface="Atkinson Hyperlegible Next"/>
               <a:ea typeface="Arial"/>
               <a:cs typeface="Arial"/>
               <a:sym typeface="Arial"/>
@@ -27439,7 +27439,7 @@
                 <a:solidFill>
                   <a:srgbClr val="E84B36"/>
                 </a:solidFill>
-                <a:latin typeface="Arial"/>
+                <a:latin typeface="Atkinson Hyperlegible Next"/>
                 <a:ea typeface="Arial"/>
                 <a:cs typeface="Arial"/>
                 <a:sym typeface="Arial"/>
@@ -27459,7 +27459,7 @@
             </a:pPr>
             <a:r>
               <a:rPr lang="en-US" sz="1800" dirty="0">
-                <a:latin typeface="Arial"/>
+                <a:latin typeface="Atkinson Hyperlegible Next"/>
                 <a:ea typeface="Arial"/>
                 <a:cs typeface="Arial"/>
                 <a:sym typeface="Arial"/>
@@ -27468,7 +27468,7 @@
             </a:r>
             <a:r>
               <a:rPr lang="en-US" sz="1800" dirty="0">
-                <a:latin typeface="Arial"/>
+                <a:latin typeface="Atkinson Hyperlegible Next"/>
                 <a:ea typeface="Arial"/>
                 <a:cs typeface="Arial"/>
                 <a:sym typeface="Arial"/>
@@ -27478,7 +27478,7 @@
             </a:r>
             <a:r>
               <a:rPr lang="en-US" sz="1800" dirty="0">
-                <a:latin typeface="Arial"/>
+                <a:latin typeface="Atkinson Hyperlegible Next"/>
                 <a:ea typeface="Arial"/>
                 <a:cs typeface="Arial"/>
                 <a:sym typeface="Arial"/>
@@ -27487,7 +27487,7 @@
             </a:r>
             <a:r>
               <a:rPr lang="en-US" sz="1800" b="1" dirty="0">
-                <a:latin typeface="Arial"/>
+                <a:latin typeface="Atkinson Hyperlegible Next"/>
                 <a:ea typeface="Arial"/>
                 <a:cs typeface="Arial"/>
                 <a:sym typeface="Arial"/>
@@ -27506,7 +27506,7 @@
               <a:buSzPts val="3000"/>
             </a:pPr>
             <a:endParaRPr lang="en-US" sz="1800" b="1" dirty="0">
-              <a:latin typeface="Arial"/>
+              <a:latin typeface="Atkinson Hyperlegible Next"/>
               <a:ea typeface="Arial"/>
               <a:cs typeface="Arial"/>
               <a:sym typeface="Arial"/>
@@ -27528,7 +27528,7 @@
                 <a:solidFill>
                   <a:srgbClr val="E84B36"/>
                 </a:solidFill>
-                <a:latin typeface="Arial"/>
+                <a:latin typeface="Atkinson Hyperlegible Next"/>
                 <a:ea typeface="Arial"/>
                 <a:cs typeface="Arial"/>
                 <a:sym typeface="Arial"/>
@@ -27536,7 +27536,7 @@
               <a:t>Small easy Quiz at the end of this lecture, like Monday, due at 11AM.</a:t>
             </a:r>
             <a:endParaRPr lang="en-US" sz="1800" b="1" dirty="0">
-              <a:latin typeface="Arial"/>
+              <a:latin typeface="Atkinson Hyperlegible Next"/>
               <a:ea typeface="Arial"/>
               <a:cs typeface="Arial"/>
               <a:sym typeface="Arial"/>
@@ -27598,7 +27598,7 @@
               <a:solidFill>
                 <a:srgbClr val="13294B"/>
               </a:solidFill>
-              <a:latin typeface="Calibri"/>
+              <a:latin typeface="Atkinson Hyperlegible Next"/>
               <a:ea typeface="Calibri"/>
               <a:cs typeface="Calibri"/>
               <a:sym typeface="Calibri"/>
@@ -27659,7 +27659,7 @@
                 <a:solidFill>
                   <a:schemeClr val="lt1"/>
                 </a:solidFill>
-                <a:latin typeface="Arial"/>
+                <a:latin typeface="Atkinson Hyperlegible Next"/>
                 <a:ea typeface="Arial"/>
                 <a:cs typeface="Arial"/>
                 <a:sym typeface="Arial"/>
@@ -27670,7 +27670,7 @@
               <a:solidFill>
                 <a:schemeClr val="lt1"/>
               </a:solidFill>
-              <a:latin typeface="Arial"/>
+              <a:latin typeface="Atkinson Hyperlegible Next"/>
               <a:ea typeface="Arial"/>
               <a:cs typeface="Arial"/>
               <a:sym typeface="Arial"/>
@@ -27759,7 +27759,7 @@
                 <a:solidFill>
                   <a:srgbClr val="13294B"/>
                 </a:solidFill>
-                <a:latin typeface="Arial"/>
+                <a:latin typeface="Atkinson Hyperlegible Next"/>
                 <a:ea typeface="Arial"/>
                 <a:cs typeface="Arial"/>
                 <a:sym typeface="Arial"/>
@@ -27926,7 +27926,7 @@
                 <a:solidFill>
                   <a:srgbClr val="13294B"/>
                 </a:solidFill>
-                <a:latin typeface="Arial"/>
+                <a:latin typeface="Atkinson Hyperlegible Next"/>
                 <a:ea typeface="Arial"/>
                 <a:cs typeface="Arial"/>
                 <a:sym typeface="Arial"/>
@@ -28021,7 +28021,7 @@
             </a:pPr>
             <a:r>
               <a:rPr lang="en-US" sz="1800" dirty="0">
-                <a:latin typeface="Arial"/>
+                <a:latin typeface="Atkinson Hyperlegible Next"/>
                 <a:ea typeface="Arial"/>
                 <a:cs typeface="Arial"/>
                 <a:sym typeface="Arial"/>
@@ -28045,7 +28045,7 @@
             </a:pPr>
             <a:r>
               <a:rPr lang="en-US" sz="1800" dirty="0">
-                <a:latin typeface="Arial"/>
+                <a:latin typeface="Atkinson Hyperlegible Next"/>
                 <a:ea typeface="Arial"/>
                 <a:cs typeface="Arial"/>
                 <a:sym typeface="Arial"/>
@@ -28068,7 +28068,7 @@
               <a:buNone/>
             </a:pPr>
             <a:endParaRPr lang="en-US" sz="1800" dirty="0">
-              <a:latin typeface="Arial"/>
+              <a:latin typeface="Atkinson Hyperlegible Next"/>
               <a:ea typeface="Arial"/>
               <a:cs typeface="Arial"/>
               <a:sym typeface="Arial"/>
@@ -28090,7 +28090,7 @@
             </a:pPr>
             <a:r>
               <a:rPr lang="en-US" sz="1800" dirty="0">
-                <a:latin typeface="Arial"/>
+                <a:latin typeface="Atkinson Hyperlegible Next"/>
                 <a:ea typeface="Arial"/>
                 <a:cs typeface="Arial"/>
                 <a:sym typeface="Arial"/>
@@ -28114,7 +28114,7 @@
             </a:pPr>
             <a:r>
               <a:rPr lang="en-US" sz="1800" dirty="0">
-                <a:latin typeface="Arial"/>
+                <a:latin typeface="Atkinson Hyperlegible Next"/>
                 <a:ea typeface="Arial"/>
                 <a:cs typeface="Arial"/>
                 <a:sym typeface="Arial"/>
@@ -28137,7 +28137,7 @@
               <a:buNone/>
             </a:pPr>
             <a:endParaRPr lang="en-US" sz="1800" dirty="0">
-              <a:latin typeface="Arial"/>
+              <a:latin typeface="Atkinson Hyperlegible Next"/>
               <a:ea typeface="Arial"/>
               <a:cs typeface="Arial"/>
               <a:sym typeface="Arial"/>
@@ -28155,7 +28155,7 @@
             </a:pPr>
             <a:r>
               <a:rPr lang="en-US" sz="1800" dirty="0">
-                <a:latin typeface="Arial"/>
+                <a:latin typeface="Atkinson Hyperlegible Next"/>
                 <a:ea typeface="Arial"/>
                 <a:cs typeface="Arial"/>
                 <a:sym typeface="Arial"/>
@@ -28164,7 +28164,7 @@
             </a:r>
             <a:r>
               <a:rPr lang="en-US" sz="1800" b="1" dirty="0">
-                <a:latin typeface="Arial"/>
+                <a:latin typeface="Atkinson Hyperlegible Next"/>
                 <a:ea typeface="Arial"/>
                 <a:cs typeface="Arial"/>
                 <a:sym typeface="Arial"/>
@@ -28173,7 +28173,7 @@
             </a:r>
             <a:r>
               <a:rPr lang="en-US" sz="1800" dirty="0">
-                <a:latin typeface="Arial"/>
+                <a:latin typeface="Atkinson Hyperlegible Next"/>
                 <a:ea typeface="Arial"/>
                 <a:cs typeface="Arial"/>
                 <a:sym typeface="Arial"/>
@@ -28193,7 +28193,7 @@
             </a:pPr>
             <a:r>
               <a:rPr lang="en-US" sz="1800" dirty="0">
-                <a:latin typeface="Arial"/>
+                <a:latin typeface="Atkinson Hyperlegible Next"/>
                 <a:ea typeface="Arial"/>
                 <a:cs typeface="Arial"/>
                 <a:sym typeface="Arial"/>
@@ -28202,7 +28202,7 @@
             </a:r>
             <a:r>
               <a:rPr lang="en-US" sz="1800" b="1" dirty="0">
-                <a:latin typeface="Arial"/>
+                <a:latin typeface="Atkinson Hyperlegible Next"/>
                 <a:ea typeface="Arial"/>
                 <a:cs typeface="Arial"/>
                 <a:sym typeface="Arial"/>
@@ -28211,7 +28211,7 @@
             </a:r>
             <a:r>
               <a:rPr lang="en-US" sz="1800" dirty="0">
-                <a:latin typeface="Arial"/>
+                <a:latin typeface="Atkinson Hyperlegible Next"/>
                 <a:ea typeface="Arial"/>
                 <a:cs typeface="Arial"/>
                 <a:sym typeface="Arial"/>
@@ -28231,7 +28231,7 @@
             </a:pPr>
             <a:r>
               <a:rPr lang="en-US" sz="1800" dirty="0">
-                <a:latin typeface="Arial"/>
+                <a:latin typeface="Atkinson Hyperlegible Next"/>
                 <a:ea typeface="Arial"/>
                 <a:cs typeface="Arial"/>
                 <a:sym typeface="Arial"/>
@@ -28240,7 +28240,7 @@
             </a:r>
             <a:r>
               <a:rPr lang="en-US" sz="1800" b="1" dirty="0">
-                <a:latin typeface="Arial"/>
+                <a:latin typeface="Atkinson Hyperlegible Next"/>
                 <a:ea typeface="Arial"/>
                 <a:cs typeface="Arial"/>
                 <a:sym typeface="Arial"/>
@@ -28249,7 +28249,7 @@
             </a:r>
             <a:r>
               <a:rPr lang="en-US" sz="1800" dirty="0">
-                <a:latin typeface="Arial"/>
+                <a:latin typeface="Atkinson Hyperlegible Next"/>
                 <a:ea typeface="Arial"/>
                 <a:cs typeface="Arial"/>
                 <a:sym typeface="Arial"/>
@@ -28269,7 +28269,7 @@
             </a:pPr>
             <a:r>
               <a:rPr lang="en-US" sz="1800" dirty="0">
-                <a:latin typeface="Arial"/>
+                <a:latin typeface="Atkinson Hyperlegible Next"/>
                 <a:ea typeface="Arial"/>
                 <a:cs typeface="Arial"/>
                 <a:sym typeface="Arial"/>
@@ -28278,7 +28278,7 @@
             </a:r>
             <a:r>
               <a:rPr lang="en-US" sz="1800" b="1" dirty="0">
-                <a:latin typeface="Arial"/>
+                <a:latin typeface="Atkinson Hyperlegible Next"/>
                 <a:ea typeface="Arial"/>
                 <a:cs typeface="Arial"/>
                 <a:sym typeface="Arial"/>
@@ -28287,7 +28287,7 @@
             </a:r>
             <a:r>
               <a:rPr lang="en-US" sz="1800" dirty="0">
-                <a:latin typeface="Arial"/>
+                <a:latin typeface="Atkinson Hyperlegible Next"/>
                 <a:ea typeface="Arial"/>
                 <a:cs typeface="Arial"/>
                 <a:sym typeface="Arial"/>
@@ -28307,7 +28307,7 @@
             </a:pPr>
             <a:r>
               <a:rPr lang="en-US" sz="1800" dirty="0">
-                <a:latin typeface="Arial"/>
+                <a:latin typeface="Atkinson Hyperlegible Next"/>
                 <a:ea typeface="Arial"/>
                 <a:cs typeface="Arial"/>
                 <a:sym typeface="Arial"/>
@@ -28316,7 +28316,7 @@
             </a:r>
             <a:r>
               <a:rPr lang="en-US" sz="1800" b="1" dirty="0">
-                <a:latin typeface="Arial"/>
+                <a:latin typeface="Atkinson Hyperlegible Next"/>
                 <a:ea typeface="Arial"/>
                 <a:cs typeface="Arial"/>
                 <a:sym typeface="Arial"/>
@@ -28325,7 +28325,7 @@
             </a:r>
             <a:r>
               <a:rPr lang="en-US" sz="1800" dirty="0">
-                <a:latin typeface="Arial"/>
+                <a:latin typeface="Atkinson Hyperlegible Next"/>
                 <a:ea typeface="Arial"/>
                 <a:cs typeface="Arial"/>
                 <a:sym typeface="Arial"/>
@@ -28345,7 +28345,7 @@
             </a:pPr>
             <a:r>
               <a:rPr lang="en-US" sz="1800" dirty="0">
-                <a:latin typeface="Arial"/>
+                <a:latin typeface="Atkinson Hyperlegible Next"/>
                 <a:ea typeface="Arial"/>
                 <a:cs typeface="Arial"/>
                 <a:sym typeface="Arial"/>
@@ -28354,7 +28354,7 @@
             </a:r>
             <a:r>
               <a:rPr lang="en-US" sz="1800" b="1" dirty="0">
-                <a:latin typeface="Arial"/>
+                <a:latin typeface="Atkinson Hyperlegible Next"/>
                 <a:ea typeface="Arial"/>
                 <a:cs typeface="Arial"/>
                 <a:sym typeface="Arial"/>
@@ -28363,7 +28363,7 @@
             </a:r>
             <a:r>
               <a:rPr lang="en-US" sz="1800" dirty="0">
-                <a:latin typeface="Arial"/>
+                <a:latin typeface="Atkinson Hyperlegible Next"/>
                 <a:ea typeface="Arial"/>
                 <a:cs typeface="Arial"/>
                 <a:sym typeface="Arial"/>
@@ -28382,7 +28382,7 @@
               <a:buSzPts val="3000"/>
             </a:pPr>
             <a:endParaRPr lang="en-US" sz="1800" dirty="0">
-              <a:latin typeface="Arial"/>
+              <a:latin typeface="Atkinson Hyperlegible Next"/>
               <a:ea typeface="Arial"/>
               <a:cs typeface="Arial"/>
               <a:sym typeface="Arial"/>
@@ -28463,7 +28463,7 @@
               <a:t> = 1;</a:t>
             </a:r>
             <a:endParaRPr lang="en-US" sz="1800" dirty="0">
-              <a:latin typeface="Arial"/>
+              <a:latin typeface="Atkinson Hyperlegible Next"/>
               <a:ea typeface="Arial"/>
               <a:cs typeface="Arial"/>
               <a:sym typeface="Arial"/>
@@ -28525,7 +28525,7 @@
               <a:solidFill>
                 <a:srgbClr val="13294B"/>
               </a:solidFill>
-              <a:latin typeface="Calibri"/>
+              <a:latin typeface="Atkinson Hyperlegible Next"/>
               <a:ea typeface="Calibri"/>
               <a:cs typeface="Calibri"/>
               <a:sym typeface="Calibri"/>
@@ -28586,7 +28586,7 @@
                 <a:solidFill>
                   <a:schemeClr val="lt1"/>
                 </a:solidFill>
-                <a:latin typeface="Arial"/>
+                <a:latin typeface="Atkinson Hyperlegible Next"/>
                 <a:ea typeface="Arial"/>
                 <a:cs typeface="Arial"/>
                 <a:sym typeface="Arial"/>
@@ -28597,7 +28597,7 @@
               <a:solidFill>
                 <a:schemeClr val="lt1"/>
               </a:solidFill>
-              <a:latin typeface="Arial"/>
+              <a:latin typeface="Atkinson Hyperlegible Next"/>
               <a:ea typeface="Arial"/>
               <a:cs typeface="Arial"/>
               <a:sym typeface="Arial"/>
@@ -28686,7 +28686,7 @@
                 <a:solidFill>
                   <a:srgbClr val="13294B"/>
                 </a:solidFill>
-                <a:latin typeface="Arial"/>
+                <a:latin typeface="Atkinson Hyperlegible Next"/>
                 <a:ea typeface="Arial"/>
                 <a:cs typeface="Arial"/>
                 <a:sym typeface="Arial"/>
@@ -28853,7 +28853,7 @@
                 <a:solidFill>
                   <a:srgbClr val="13294B"/>
                 </a:solidFill>
-                <a:latin typeface="Arial"/>
+                <a:latin typeface="Atkinson Hyperlegible Next"/>
                 <a:ea typeface="Arial"/>
                 <a:cs typeface="Arial"/>
                 <a:sym typeface="Arial"/>
@@ -29076,7 +29076,7 @@
               <a:solidFill>
                 <a:srgbClr val="13294B"/>
               </a:solidFill>
-              <a:latin typeface="Calibri"/>
+              <a:latin typeface="Atkinson Hyperlegible Next"/>
               <a:ea typeface="Calibri"/>
               <a:cs typeface="Calibri"/>
               <a:sym typeface="Calibri"/>
@@ -29137,7 +29137,7 @@
                 <a:solidFill>
                   <a:schemeClr val="lt1"/>
                 </a:solidFill>
-                <a:latin typeface="Arial"/>
+                <a:latin typeface="Atkinson Hyperlegible Next"/>
                 <a:ea typeface="Arial"/>
                 <a:cs typeface="Arial"/>
                 <a:sym typeface="Arial"/>
@@ -29148,7 +29148,7 @@
               <a:solidFill>
                 <a:schemeClr val="lt1"/>
               </a:solidFill>
-              <a:latin typeface="Arial"/>
+              <a:latin typeface="Atkinson Hyperlegible Next"/>
               <a:ea typeface="Arial"/>
               <a:cs typeface="Arial"/>
               <a:sym typeface="Arial"/>
@@ -29237,7 +29237,7 @@
                 <a:solidFill>
                   <a:srgbClr val="13294B"/>
                 </a:solidFill>
-                <a:latin typeface="Arial"/>
+                <a:latin typeface="Atkinson Hyperlegible Next"/>
                 <a:ea typeface="Arial"/>
                 <a:cs typeface="Arial"/>
                 <a:sym typeface="Arial"/>
@@ -29404,7 +29404,7 @@
                 <a:solidFill>
                   <a:srgbClr val="13294B"/>
                 </a:solidFill>
-                <a:latin typeface="Arial"/>
+                <a:latin typeface="Atkinson Hyperlegible Next"/>
                 <a:ea typeface="Arial"/>
                 <a:cs typeface="Arial"/>
                 <a:sym typeface="Arial"/>
@@ -31123,7 +31123,7 @@
               <a:solidFill>
                 <a:srgbClr val="13294B"/>
               </a:solidFill>
-              <a:latin typeface="Calibri"/>
+              <a:latin typeface="Atkinson Hyperlegible Next"/>
               <a:ea typeface="Calibri"/>
               <a:cs typeface="Calibri"/>
               <a:sym typeface="Calibri"/>
@@ -31184,7 +31184,7 @@
                 <a:solidFill>
                   <a:schemeClr val="lt1"/>
                 </a:solidFill>
-                <a:latin typeface="Arial"/>
+                <a:latin typeface="Atkinson Hyperlegible Next"/>
                 <a:ea typeface="Arial"/>
                 <a:cs typeface="Arial"/>
                 <a:sym typeface="Arial"/>
@@ -31195,7 +31195,7 @@
               <a:solidFill>
                 <a:schemeClr val="lt1"/>
               </a:solidFill>
-              <a:latin typeface="Arial"/>
+              <a:latin typeface="Atkinson Hyperlegible Next"/>
               <a:ea typeface="Arial"/>
               <a:cs typeface="Arial"/>
               <a:sym typeface="Arial"/>
@@ -31284,7 +31284,7 @@
                 <a:solidFill>
                   <a:srgbClr val="13294B"/>
                 </a:solidFill>
-                <a:latin typeface="Arial"/>
+                <a:latin typeface="Atkinson Hyperlegible Next"/>
                 <a:ea typeface="Arial"/>
                 <a:cs typeface="Arial"/>
                 <a:sym typeface="Arial"/>
@@ -31451,7 +31451,7 @@
                 <a:solidFill>
                   <a:srgbClr val="13294B"/>
                 </a:solidFill>
-                <a:latin typeface="Arial"/>
+                <a:latin typeface="Atkinson Hyperlegible Next"/>
                 <a:ea typeface="Arial"/>
                 <a:cs typeface="Arial"/>
                 <a:sym typeface="Arial"/>
@@ -31750,7 +31750,7 @@
               <a:solidFill>
                 <a:srgbClr val="13294B"/>
               </a:solidFill>
-              <a:latin typeface="Calibri"/>
+              <a:latin typeface="Atkinson Hyperlegible Next"/>
               <a:ea typeface="Calibri"/>
               <a:cs typeface="Calibri"/>
               <a:sym typeface="Calibri"/>
@@ -31811,7 +31811,7 @@
                 <a:solidFill>
                   <a:schemeClr val="lt1"/>
                 </a:solidFill>
-                <a:latin typeface="Arial"/>
+                <a:latin typeface="Atkinson Hyperlegible Next"/>
                 <a:ea typeface="Arial"/>
                 <a:cs typeface="Arial"/>
                 <a:sym typeface="Arial"/>
@@ -31823,7 +31823,7 @@
                 <a:solidFill>
                   <a:schemeClr val="lt1"/>
                 </a:solidFill>
-                <a:latin typeface="Arial"/>
+                <a:latin typeface="Atkinson Hyperlegible Next"/>
                 <a:ea typeface="Arial"/>
                 <a:cs typeface="Arial"/>
                 <a:sym typeface="Arial"/>
@@ -31835,7 +31835,7 @@
                 <a:solidFill>
                   <a:schemeClr val="lt1"/>
                 </a:solidFill>
-                <a:latin typeface="Arial"/>
+                <a:latin typeface="Atkinson Hyperlegible Next"/>
                 <a:ea typeface="Arial"/>
                 <a:cs typeface="Arial"/>
                 <a:sym typeface="Arial"/>
@@ -31846,7 +31846,7 @@
               <a:solidFill>
                 <a:schemeClr val="lt1"/>
               </a:solidFill>
-              <a:latin typeface="Arial"/>
+              <a:latin typeface="Atkinson Hyperlegible Next"/>
               <a:ea typeface="Arial"/>
               <a:cs typeface="Arial"/>
               <a:sym typeface="Arial"/>
@@ -31935,7 +31935,7 @@
                 <a:solidFill>
                   <a:srgbClr val="13294B"/>
                 </a:solidFill>
-                <a:latin typeface="Arial"/>
+                <a:latin typeface="Atkinson Hyperlegible Next"/>
                 <a:ea typeface="Arial"/>
                 <a:cs typeface="Arial"/>
                 <a:sym typeface="Arial"/>
@@ -32102,7 +32102,7 @@
                 <a:solidFill>
                   <a:srgbClr val="13294B"/>
                 </a:solidFill>
-                <a:latin typeface="Arial"/>
+                <a:latin typeface="Atkinson Hyperlegible Next"/>
                 <a:ea typeface="Arial"/>
                 <a:cs typeface="Arial"/>
                 <a:sym typeface="Arial"/>
@@ -32213,7 +32213,7 @@
                 <a:solidFill>
                   <a:srgbClr val="15264B"/>
                 </a:solidFill>
-                <a:latin typeface="Arial"/>
+                <a:latin typeface="Atkinson Hyperlegible Next"/>
                 <a:ea typeface="Arial"/>
                 <a:cs typeface="Arial"/>
                 <a:sym typeface="Arial"/>
@@ -32390,7 +32390,7 @@
                 <a:solidFill>
                   <a:srgbClr val="13294B"/>
                 </a:solidFill>
-                <a:latin typeface="Arial"/>
+                <a:latin typeface="Atkinson Hyperlegible Next"/>
                 <a:ea typeface="Arial"/>
                 <a:cs typeface="Arial"/>
                 <a:sym typeface="Arial"/>
@@ -32557,7 +32557,7 @@
                 <a:solidFill>
                   <a:srgbClr val="13294B"/>
                 </a:solidFill>
-                <a:latin typeface="Arial"/>
+                <a:latin typeface="Atkinson Hyperlegible Next"/>
                 <a:ea typeface="Arial"/>
                 <a:cs typeface="Arial"/>
                 <a:sym typeface="Arial"/>
@@ -32708,7 +32708,7 @@
               <a:solidFill>
                 <a:srgbClr val="13294B"/>
               </a:solidFill>
-              <a:latin typeface="Calibri"/>
+              <a:latin typeface="Atkinson Hyperlegible Next"/>
               <a:ea typeface="Calibri"/>
               <a:cs typeface="Calibri"/>
               <a:sym typeface="Calibri"/>
@@ -32769,7 +32769,7 @@
                 <a:solidFill>
                   <a:schemeClr val="lt1"/>
                 </a:solidFill>
-                <a:latin typeface="Arial"/>
+                <a:latin typeface="Atkinson Hyperlegible Next"/>
                 <a:ea typeface="Arial"/>
                 <a:cs typeface="Arial"/>
                 <a:sym typeface="Arial"/>
@@ -32780,7 +32780,7 @@
               <a:solidFill>
                 <a:schemeClr val="lt1"/>
               </a:solidFill>
-              <a:latin typeface="Arial"/>
+              <a:latin typeface="Atkinson Hyperlegible Next"/>
               <a:ea typeface="Arial"/>
               <a:cs typeface="Arial"/>
               <a:sym typeface="Arial"/>
@@ -32869,7 +32869,7 @@
                 <a:solidFill>
                   <a:srgbClr val="13294B"/>
                 </a:solidFill>
-                <a:latin typeface="Arial"/>
+                <a:latin typeface="Atkinson Hyperlegible Next"/>
                 <a:ea typeface="Arial"/>
                 <a:cs typeface="Arial"/>
                 <a:sym typeface="Arial"/>
@@ -33036,7 +33036,7 @@
                 <a:solidFill>
                   <a:srgbClr val="13294B"/>
                 </a:solidFill>
-                <a:latin typeface="Arial"/>
+                <a:latin typeface="Atkinson Hyperlegible Next"/>
                 <a:ea typeface="Arial"/>
                 <a:cs typeface="Arial"/>
                 <a:sym typeface="Arial"/>
@@ -33998,7 +33998,7 @@
                 <a:solidFill>
                   <a:schemeClr val="lt1"/>
                 </a:solidFill>
-                <a:latin typeface="Arial"/>
+                <a:latin typeface="Atkinson Hyperlegible Next"/>
                 <a:ea typeface="Arial"/>
                 <a:cs typeface="Arial"/>
                 <a:sym typeface="Arial"/>
@@ -34165,7 +34165,7 @@
                 <a:solidFill>
                   <a:schemeClr val="lt1"/>
                 </a:solidFill>
-                <a:latin typeface="Arial"/>
+                <a:latin typeface="Atkinson Hyperlegible Next"/>
                 <a:ea typeface="Arial"/>
                 <a:cs typeface="Arial"/>
                 <a:sym typeface="Arial"/>
@@ -34341,7 +34341,7 @@
                 <a:solidFill>
                   <a:schemeClr val="lt1"/>
                 </a:solidFill>
-                <a:latin typeface="Arial"/>
+                <a:latin typeface="Atkinson Hyperlegible Next"/>
                 <a:ea typeface="Arial"/>
                 <a:cs typeface="Arial"/>
                 <a:sym typeface="Arial"/>
@@ -34352,7 +34352,7 @@
               <a:solidFill>
                 <a:srgbClr val="000000"/>
               </a:solidFill>
-              <a:latin typeface="Arial"/>
+              <a:latin typeface="Atkinson Hyperlegible Next"/>
               <a:ea typeface="Arial"/>
               <a:cs typeface="Arial"/>
               <a:sym typeface="Arial"/>
@@ -34526,7 +34526,7 @@
                 <a:solidFill>
                   <a:schemeClr val="lt1"/>
                 </a:solidFill>
-                <a:latin typeface="Arial"/>
+                <a:latin typeface="Atkinson Hyperlegible Next"/>
                 <a:ea typeface="Arial"/>
                 <a:cs typeface="Arial"/>
                 <a:sym typeface="Arial"/>
@@ -34693,7 +34693,7 @@
                 <a:solidFill>
                   <a:schemeClr val="lt1"/>
                 </a:solidFill>
-                <a:latin typeface="Arial"/>
+                <a:latin typeface="Atkinson Hyperlegible Next"/>
                 <a:ea typeface="Arial"/>
                 <a:cs typeface="Arial"/>
                 <a:sym typeface="Arial"/>
@@ -34755,7 +34755,7 @@
                 <a:solidFill>
                   <a:schemeClr val="lt1"/>
                 </a:solidFill>
-                <a:latin typeface="Arial"/>
+                <a:latin typeface="Atkinson Hyperlegible Next"/>
                 <a:ea typeface="Arial"/>
                 <a:cs typeface="Arial"/>
                 <a:sym typeface="Arial"/>
@@ -34793,7 +34793,7 @@
               <a:solidFill>
                 <a:schemeClr val="lt1"/>
               </a:solidFill>
-              <a:latin typeface="Arial"/>
+              <a:latin typeface="Atkinson Hyperlegible Next"/>
               <a:ea typeface="Arial"/>
               <a:cs typeface="Arial"/>
               <a:sym typeface="Arial"/>
@@ -34891,7 +34891,7 @@
                 <a:solidFill>
                   <a:srgbClr val="15264B"/>
                 </a:solidFill>
-                <a:latin typeface="Arial"/>
+                <a:latin typeface="Atkinson Hyperlegible Next"/>
                 <a:ea typeface="Arial"/>
                 <a:cs typeface="Arial"/>
                 <a:sym typeface="Arial"/>
@@ -35038,7 +35038,7 @@
                 <a:solidFill>
                   <a:srgbClr val="13294B"/>
                 </a:solidFill>
-                <a:latin typeface="Arial"/>
+                <a:latin typeface="Atkinson Hyperlegible Next"/>
                 <a:ea typeface="Arial"/>
                 <a:cs typeface="Arial"/>
                 <a:sym typeface="Arial"/>
@@ -35181,7 +35181,7 @@
                 <a:solidFill>
                   <a:srgbClr val="13294B"/>
                 </a:solidFill>
-                <a:latin typeface="Arial"/>
+                <a:latin typeface="Atkinson Hyperlegible Next"/>
                 <a:ea typeface="Arial"/>
                 <a:cs typeface="Arial"/>
                 <a:sym typeface="Arial"/>
@@ -35591,7 +35591,7 @@
               <a:solidFill>
                 <a:srgbClr val="13294B"/>
               </a:solidFill>
-              <a:latin typeface="Calibri"/>
+              <a:latin typeface="Atkinson Hyperlegible Next"/>
               <a:ea typeface="Calibri"/>
               <a:cs typeface="Calibri"/>
               <a:sym typeface="Calibri"/>
@@ -35646,7 +35646,7 @@
                 <a:solidFill>
                   <a:schemeClr val="lt1"/>
                 </a:solidFill>
-                <a:latin typeface="Arial"/>
+                <a:latin typeface="Atkinson Hyperlegible Next"/>
                 <a:ea typeface="Arial"/>
                 <a:cs typeface="Arial"/>
                 <a:sym typeface="Arial"/>
@@ -35657,7 +35657,7 @@
               <a:solidFill>
                 <a:schemeClr val="lt1"/>
               </a:solidFill>
-              <a:latin typeface="Arial"/>
+              <a:latin typeface="Atkinson Hyperlegible Next"/>
               <a:ea typeface="Arial"/>
               <a:cs typeface="Arial"/>
               <a:sym typeface="Arial"/>
@@ -35734,7 +35734,7 @@
                 <a:solidFill>
                   <a:srgbClr val="13294B"/>
                 </a:solidFill>
-                <a:latin typeface="Arial"/>
+                <a:latin typeface="Atkinson Hyperlegible Next"/>
                 <a:ea typeface="Arial"/>
                 <a:cs typeface="Arial"/>
                 <a:sym typeface="Arial"/>
@@ -35877,7 +35877,7 @@
                 <a:solidFill>
                   <a:srgbClr val="13294B"/>
                 </a:solidFill>
-                <a:latin typeface="Arial"/>
+                <a:latin typeface="Atkinson Hyperlegible Next"/>
                 <a:ea typeface="Arial"/>
                 <a:cs typeface="Arial"/>
                 <a:sym typeface="Arial"/>
@@ -36309,7 +36309,7 @@
               <a:solidFill>
                 <a:srgbClr val="13294B"/>
               </a:solidFill>
-              <a:latin typeface="Calibri"/>
+              <a:latin typeface="Atkinson Hyperlegible Next"/>
               <a:ea typeface="Calibri"/>
               <a:cs typeface="Calibri"/>
               <a:sym typeface="Calibri"/>
@@ -36370,7 +36370,7 @@
                 <a:solidFill>
                   <a:schemeClr val="lt1"/>
                 </a:solidFill>
-                <a:latin typeface="Arial"/>
+                <a:latin typeface="Atkinson Hyperlegible Next"/>
                 <a:ea typeface="Arial"/>
                 <a:cs typeface="Arial"/>
                 <a:sym typeface="Arial"/>
@@ -36381,7 +36381,7 @@
               <a:solidFill>
                 <a:schemeClr val="lt1"/>
               </a:solidFill>
-              <a:latin typeface="Arial"/>
+              <a:latin typeface="Atkinson Hyperlegible Next"/>
               <a:ea typeface="Arial"/>
               <a:cs typeface="Arial"/>
               <a:sym typeface="Arial"/>
@@ -36470,7 +36470,7 @@
                 <a:solidFill>
                   <a:srgbClr val="13294B"/>
                 </a:solidFill>
-                <a:latin typeface="Arial"/>
+                <a:latin typeface="Atkinson Hyperlegible Next"/>
                 <a:ea typeface="Arial"/>
                 <a:cs typeface="Arial"/>
                 <a:sym typeface="Arial"/>
@@ -36637,7 +36637,7 @@
                 <a:solidFill>
                   <a:srgbClr val="13294B"/>
                 </a:solidFill>
-                <a:latin typeface="Arial"/>
+                <a:latin typeface="Atkinson Hyperlegible Next"/>
                 <a:ea typeface="Arial"/>
                 <a:cs typeface="Arial"/>
                 <a:sym typeface="Arial"/>
@@ -36913,7 +36913,7 @@
               <a:solidFill>
                 <a:srgbClr val="13294B"/>
               </a:solidFill>
-              <a:latin typeface="Calibri"/>
+              <a:latin typeface="Atkinson Hyperlegible Next"/>
               <a:ea typeface="Calibri"/>
               <a:cs typeface="Calibri"/>
               <a:sym typeface="Calibri"/>
@@ -36974,7 +36974,7 @@
                 <a:solidFill>
                   <a:schemeClr val="lt1"/>
                 </a:solidFill>
-                <a:latin typeface="Arial"/>
+                <a:latin typeface="Atkinson Hyperlegible Next"/>
                 <a:ea typeface="Arial"/>
                 <a:cs typeface="Arial"/>
                 <a:sym typeface="Arial"/>
@@ -36985,7 +36985,7 @@
               <a:solidFill>
                 <a:schemeClr val="lt1"/>
               </a:solidFill>
-              <a:latin typeface="Arial"/>
+              <a:latin typeface="Atkinson Hyperlegible Next"/>
               <a:ea typeface="Arial"/>
               <a:cs typeface="Arial"/>
               <a:sym typeface="Arial"/>
@@ -37074,7 +37074,7 @@
                 <a:solidFill>
                   <a:srgbClr val="13294B"/>
                 </a:solidFill>
-                <a:latin typeface="Arial"/>
+                <a:latin typeface="Atkinson Hyperlegible Next"/>
                 <a:ea typeface="Arial"/>
                 <a:cs typeface="Arial"/>
                 <a:sym typeface="Arial"/>
@@ -37241,7 +37241,7 @@
                 <a:solidFill>
                   <a:srgbClr val="13294B"/>
                 </a:solidFill>
-                <a:latin typeface="Arial"/>
+                <a:latin typeface="Atkinson Hyperlegible Next"/>
                 <a:ea typeface="Arial"/>
                 <a:cs typeface="Arial"/>
                 <a:sym typeface="Arial"/>
@@ -37806,7 +37806,7 @@
               <a:solidFill>
                 <a:srgbClr val="13294B"/>
               </a:solidFill>
-              <a:latin typeface="Calibri"/>
+              <a:latin typeface="Atkinson Hyperlegible Next"/>
               <a:ea typeface="Calibri"/>
               <a:cs typeface="Calibri"/>
               <a:sym typeface="Calibri"/>
@@ -37867,7 +37867,7 @@
                 <a:solidFill>
                   <a:schemeClr val="lt1"/>
                 </a:solidFill>
-                <a:latin typeface="Arial"/>
+                <a:latin typeface="Atkinson Hyperlegible Next"/>
                 <a:ea typeface="Arial"/>
                 <a:cs typeface="Arial"/>
                 <a:sym typeface="Arial"/>
@@ -37878,7 +37878,7 @@
               <a:solidFill>
                 <a:schemeClr val="lt1"/>
               </a:solidFill>
-              <a:latin typeface="Arial"/>
+              <a:latin typeface="Atkinson Hyperlegible Next"/>
               <a:ea typeface="Arial"/>
               <a:cs typeface="Arial"/>
               <a:sym typeface="Arial"/>
@@ -37967,7 +37967,7 @@
                 <a:solidFill>
                   <a:srgbClr val="13294B"/>
                 </a:solidFill>
-                <a:latin typeface="Arial"/>
+                <a:latin typeface="Atkinson Hyperlegible Next"/>
                 <a:ea typeface="Arial"/>
                 <a:cs typeface="Arial"/>
                 <a:sym typeface="Arial"/>
@@ -38134,7 +38134,7 @@
                 <a:solidFill>
                   <a:srgbClr val="13294B"/>
                 </a:solidFill>
-                <a:latin typeface="Arial"/>
+                <a:latin typeface="Atkinson Hyperlegible Next"/>
                 <a:ea typeface="Arial"/>
                 <a:cs typeface="Arial"/>
                 <a:sym typeface="Arial"/>
@@ -38269,7 +38269,7 @@
               <a:solidFill>
                 <a:srgbClr val="13294B"/>
               </a:solidFill>
-              <a:latin typeface="Calibri"/>
+              <a:latin typeface="Atkinson Hyperlegible Next"/>
               <a:ea typeface="Calibri"/>
               <a:cs typeface="Calibri"/>
               <a:sym typeface="Calibri"/>
@@ -38330,7 +38330,7 @@
                 <a:solidFill>
                   <a:schemeClr val="lt1"/>
                 </a:solidFill>
-                <a:latin typeface="Arial"/>
+                <a:latin typeface="Atkinson Hyperlegible Next"/>
                 <a:ea typeface="Arial"/>
                 <a:cs typeface="Arial"/>
                 <a:sym typeface="Arial"/>
@@ -38341,7 +38341,7 @@
               <a:solidFill>
                 <a:schemeClr val="lt1"/>
               </a:solidFill>
-              <a:latin typeface="Arial"/>
+              <a:latin typeface="Atkinson Hyperlegible Next"/>
               <a:ea typeface="Arial"/>
               <a:cs typeface="Arial"/>
               <a:sym typeface="Arial"/>
@@ -38430,7 +38430,7 @@
                 <a:solidFill>
                   <a:srgbClr val="13294B"/>
                 </a:solidFill>
-                <a:latin typeface="Arial"/>
+                <a:latin typeface="Atkinson Hyperlegible Next"/>
                 <a:ea typeface="Arial"/>
                 <a:cs typeface="Arial"/>
                 <a:sym typeface="Arial"/>
@@ -38597,7 +38597,7 @@
                 <a:solidFill>
                   <a:srgbClr val="13294B"/>
                 </a:solidFill>
-                <a:latin typeface="Arial"/>
+                <a:latin typeface="Atkinson Hyperlegible Next"/>
                 <a:ea typeface="Arial"/>
                 <a:cs typeface="Arial"/>
                 <a:sym typeface="Arial"/>
@@ -38872,7 +38872,7 @@
     </a:clrScheme>
     <a:fontScheme name="Office">
       <a:majorFont>
-        <a:latin typeface="Arial"/>
+        <a:latin typeface="Atkinson Hyperlegible Next"/>
         <a:ea typeface=""/>
         <a:cs typeface=""/>
         <a:font script="Jpan" typeface="ＭＳ Ｐゴシック"/>
@@ -38907,7 +38907,7 @@
         <a:font script="Geor" typeface="Sylfaen"/>
       </a:majorFont>
       <a:minorFont>
-        <a:latin typeface="Arial"/>
+        <a:latin typeface="Atkinson Hyperlegible Next"/>
         <a:ea typeface=""/>
         <a:cs typeface=""/>
         <a:font script="Jpan" typeface="ＭＳ Ｐゴシック"/>
@@ -39153,7 +39153,7 @@
     </a:clrScheme>
     <a:fontScheme name="Office">
       <a:majorFont>
-        <a:latin typeface="Arial"/>
+        <a:latin typeface="Atkinson Hyperlegible Next"/>
         <a:ea typeface=""/>
         <a:cs typeface=""/>
         <a:font script="Jpan" typeface="ＭＳ Ｐゴシック"/>
@@ -39188,7 +39188,7 @@
         <a:font script="Geor" typeface="Sylfaen"/>
       </a:majorFont>
       <a:minorFont>
-        <a:latin typeface="Arial"/>
+        <a:latin typeface="Atkinson Hyperlegible Next"/>
         <a:ea typeface=""/>
         <a:cs typeface=""/>
         <a:font script="Jpan" typeface="ＭＳ Ｐゴシック"/>

</xml_diff>

<commit_message>
Move the L3 push-pull animation to-do from the slides to the README
Slides 13-14 showed "( I wanted to create the animation for this... )" to
students; the text box is removed (only those two slide parts change, renders
reviewed) and the to-do is in the README's notes to professors.

Co-Authored-By: Claude Opus 5.5 <noreply@anthropic.com>
Claude-Session: https://claude.ai/code/session_019w92gFNgKGkHAyPsWs6PXG
</commit_message>
<xml_diff>
--- a/Lectures/Slides/L3.pptx
+++ b/Lectures/Slides/L3.pptx
@@ -23856,41 +23856,6 @@
       </p:pic>
       <p:sp>
         <p:nvSpPr>
-          <p:cNvPr id="3" name="TextBox 2">
-            <a:extLst>
-              <a:ext uri="{FF2B5EF4-FFF2-40B4-BE49-F238E27FC236}">
-                <a16:creationId xmlns:a16="http://schemas.microsoft.com/office/drawing/2014/main" id="{804A23D2-91C4-10D1-67EE-23EA4D179FAB}"/>
-              </a:ext>
-            </a:extLst>
-          </p:cNvPr>
-          <p:cNvSpPr txBox="1"/>
-          <p:nvPr/>
-        </p:nvSpPr>
-        <p:spPr>
-          <a:xfrm>
-            <a:off x="6934861" y="5591906"/>
-            <a:ext cx="4730449" cy="523220"/>
-          </a:xfrm>
-          <a:prstGeom prst="rect">
-            <a:avLst/>
-          </a:prstGeom>
-          <a:noFill/>
-        </p:spPr>
-        <p:txBody>
-          <a:bodyPr wrap="square" rtlCol="0">
-            <a:spAutoFit/>
-          </a:bodyPr>
-          <a:lstStyle/>
-          <a:p>
-            <a:r>
-              <a:rPr lang="en-US" dirty="0"/>
-              <a:t>( I wanted to create the animation for this, but if this text is still here, then it has not been done yet.) </a:t>
-            </a:r>
-          </a:p>
-        </p:txBody>
-      </p:sp>
-      <p:sp>
-        <p:nvSpPr>
           <p:cNvPr id="4" name="TextBox 3">
             <a:extLst>
               <a:ext uri="{FF2B5EF4-FFF2-40B4-BE49-F238E27FC236}">
@@ -24600,41 +24565,6 @@
           </a:extLst>
         </p:spPr>
       </p:pic>
-      <p:sp>
-        <p:nvSpPr>
-          <p:cNvPr id="3" name="TextBox 2">
-            <a:extLst>
-              <a:ext uri="{FF2B5EF4-FFF2-40B4-BE49-F238E27FC236}">
-                <a16:creationId xmlns:a16="http://schemas.microsoft.com/office/drawing/2014/main" id="{AFAA4260-9A40-D891-BB00-75F7BBEAEF59}"/>
-              </a:ext>
-            </a:extLst>
-          </p:cNvPr>
-          <p:cNvSpPr txBox="1"/>
-          <p:nvPr/>
-        </p:nvSpPr>
-        <p:spPr>
-          <a:xfrm>
-            <a:off x="6934861" y="5591906"/>
-            <a:ext cx="4730449" cy="523220"/>
-          </a:xfrm>
-          <a:prstGeom prst="rect">
-            <a:avLst/>
-          </a:prstGeom>
-          <a:noFill/>
-        </p:spPr>
-        <p:txBody>
-          <a:bodyPr wrap="square" rtlCol="0">
-            <a:spAutoFit/>
-          </a:bodyPr>
-          <a:lstStyle/>
-          <a:p>
-            <a:r>
-              <a:rPr lang="en-US" dirty="0"/>
-              <a:t>( I wanted to create the animation for this, but if this text is still here, then it has not been done yet.) </a:t>
-            </a:r>
-          </a:p>
-        </p:txBody>
-      </p:sp>
       <p:sp>
         <p:nvSpPr>
           <p:cNvPr id="4" name="TextBox 3">

</xml_diff>

<commit_message>
L3 animation to-do to the README; unnumber HW6's Kalman heading (#27)
</commit_message>
<xml_diff>
--- a/Lectures/Slides/L3.pptx
+++ b/Lectures/Slides/L3.pptx
@@ -23856,41 +23856,6 @@
       </p:pic>
       <p:sp>
         <p:nvSpPr>
-          <p:cNvPr id="3" name="TextBox 2">
-            <a:extLst>
-              <a:ext uri="{FF2B5EF4-FFF2-40B4-BE49-F238E27FC236}">
-                <a16:creationId xmlns:a16="http://schemas.microsoft.com/office/drawing/2014/main" id="{804A23D2-91C4-10D1-67EE-23EA4D179FAB}"/>
-              </a:ext>
-            </a:extLst>
-          </p:cNvPr>
-          <p:cNvSpPr txBox="1"/>
-          <p:nvPr/>
-        </p:nvSpPr>
-        <p:spPr>
-          <a:xfrm>
-            <a:off x="6934861" y="5591906"/>
-            <a:ext cx="4730449" cy="523220"/>
-          </a:xfrm>
-          <a:prstGeom prst="rect">
-            <a:avLst/>
-          </a:prstGeom>
-          <a:noFill/>
-        </p:spPr>
-        <p:txBody>
-          <a:bodyPr wrap="square" rtlCol="0">
-            <a:spAutoFit/>
-          </a:bodyPr>
-          <a:lstStyle/>
-          <a:p>
-            <a:r>
-              <a:rPr lang="en-US" dirty="0"/>
-              <a:t>( I wanted to create the animation for this, but if this text is still here, then it has not been done yet.) </a:t>
-            </a:r>
-          </a:p>
-        </p:txBody>
-      </p:sp>
-      <p:sp>
-        <p:nvSpPr>
           <p:cNvPr id="4" name="TextBox 3">
             <a:extLst>
               <a:ext uri="{FF2B5EF4-FFF2-40B4-BE49-F238E27FC236}">
@@ -24600,41 +24565,6 @@
           </a:extLst>
         </p:spPr>
       </p:pic>
-      <p:sp>
-        <p:nvSpPr>
-          <p:cNvPr id="3" name="TextBox 2">
-            <a:extLst>
-              <a:ext uri="{FF2B5EF4-FFF2-40B4-BE49-F238E27FC236}">
-                <a16:creationId xmlns:a16="http://schemas.microsoft.com/office/drawing/2014/main" id="{AFAA4260-9A40-D891-BB00-75F7BBEAEF59}"/>
-              </a:ext>
-            </a:extLst>
-          </p:cNvPr>
-          <p:cNvSpPr txBox="1"/>
-          <p:nvPr/>
-        </p:nvSpPr>
-        <p:spPr>
-          <a:xfrm>
-            <a:off x="6934861" y="5591906"/>
-            <a:ext cx="4730449" cy="523220"/>
-          </a:xfrm>
-          <a:prstGeom prst="rect">
-            <a:avLst/>
-          </a:prstGeom>
-          <a:noFill/>
-        </p:spPr>
-        <p:txBody>
-          <a:bodyPr wrap="square" rtlCol="0">
-            <a:spAutoFit/>
-          </a:bodyPr>
-          <a:lstStyle/>
-          <a:p>
-            <a:r>
-              <a:rPr lang="en-US" dirty="0"/>
-              <a:t>( I wanted to create the animation for this, but if this text is still here, then it has not been done yet.) </a:t>
-            </a:r>
-          </a:p>
-        </p:txBody>
-      </p:sp>
       <p:sp>
         <p:nvSpPr>
           <p:cNvPr id="4" name="TextBox 3">

</xml_diff>

<commit_message>
Incremental Build at 2026-10-17 16:06:35
</commit_message>
<xml_diff>
--- a/Lectures/Slides/L3.pptx
+++ b/Lectures/Slides/L3.pptx
@@ -23856,41 +23856,6 @@
       </p:pic>
       <p:sp>
         <p:nvSpPr>
-          <p:cNvPr id="3" name="TextBox 2">
-            <a:extLst>
-              <a:ext uri="{FF2B5EF4-FFF2-40B4-BE49-F238E27FC236}">
-                <a16:creationId xmlns:a16="http://schemas.microsoft.com/office/drawing/2014/main" id="{804A23D2-91C4-10D1-67EE-23EA4D179FAB}"/>
-              </a:ext>
-            </a:extLst>
-          </p:cNvPr>
-          <p:cNvSpPr txBox="1"/>
-          <p:nvPr/>
-        </p:nvSpPr>
-        <p:spPr>
-          <a:xfrm>
-            <a:off x="6934861" y="5591906"/>
-            <a:ext cx="4730449" cy="523220"/>
-          </a:xfrm>
-          <a:prstGeom prst="rect">
-            <a:avLst/>
-          </a:prstGeom>
-          <a:noFill/>
-        </p:spPr>
-        <p:txBody>
-          <a:bodyPr wrap="square" rtlCol="0">
-            <a:spAutoFit/>
-          </a:bodyPr>
-          <a:lstStyle/>
-          <a:p>
-            <a:r>
-              <a:rPr lang="en-US" dirty="0"/>
-              <a:t>( I wanted to create the animation for this, but if this text is still here, then it has not been done yet.) </a:t>
-            </a:r>
-          </a:p>
-        </p:txBody>
-      </p:sp>
-      <p:sp>
-        <p:nvSpPr>
           <p:cNvPr id="4" name="TextBox 3">
             <a:extLst>
               <a:ext uri="{FF2B5EF4-FFF2-40B4-BE49-F238E27FC236}">
@@ -24600,41 +24565,6 @@
           </a:extLst>
         </p:spPr>
       </p:pic>
-      <p:sp>
-        <p:nvSpPr>
-          <p:cNvPr id="3" name="TextBox 2">
-            <a:extLst>
-              <a:ext uri="{FF2B5EF4-FFF2-40B4-BE49-F238E27FC236}">
-                <a16:creationId xmlns:a16="http://schemas.microsoft.com/office/drawing/2014/main" id="{AFAA4260-9A40-D891-BB00-75F7BBEAEF59}"/>
-              </a:ext>
-            </a:extLst>
-          </p:cNvPr>
-          <p:cNvSpPr txBox="1"/>
-          <p:nvPr/>
-        </p:nvSpPr>
-        <p:spPr>
-          <a:xfrm>
-            <a:off x="6934861" y="5591906"/>
-            <a:ext cx="4730449" cy="523220"/>
-          </a:xfrm>
-          <a:prstGeom prst="rect">
-            <a:avLst/>
-          </a:prstGeom>
-          <a:noFill/>
-        </p:spPr>
-        <p:txBody>
-          <a:bodyPr wrap="square" rtlCol="0">
-            <a:spAutoFit/>
-          </a:bodyPr>
-          <a:lstStyle/>
-          <a:p>
-            <a:r>
-              <a:rPr lang="en-US" dirty="0"/>
-              <a:t>( I wanted to create the animation for this, but if this text is still here, then it has not been done yet.) </a:t>
-            </a:r>
-          </a:p>
-        </p:txBody>
-      </p:sp>
       <p:sp>
         <p:nvSpPr>
           <p:cNvPr id="4" name="TextBox 3">

</xml_diff>

<commit_message>
Move the L3 slide 21 animation to-do to the README
The same placeholder as slides 13-14 was also on slide 21 (Pin Mux (4/4)),
visible to students; the text box is removed (only slide21.xml changes,
render reviewed) and the to-do joins the README's L3 notes.

Co-Authored-By: Claude Opus 5.5 <noreply@anthropic.com>
Claude-Session: https://claude.ai/code/session_019w92gFNgKGkHAyPsWs6PXG
</commit_message>
<xml_diff>
--- a/Lectures/Slides/L3.pptx
+++ b/Lectures/Slides/L3.pptx
@@ -31010,41 +31010,6 @@
       </p:pic>
       <p:sp>
         <p:nvSpPr>
-          <p:cNvPr id="7" name="TextBox 6">
-            <a:extLst>
-              <a:ext uri="{FF2B5EF4-FFF2-40B4-BE49-F238E27FC236}">
-                <a16:creationId xmlns:a16="http://schemas.microsoft.com/office/drawing/2014/main" id="{7E111A22-27B9-C2D3-DD45-1E7F5E82C23B}"/>
-              </a:ext>
-            </a:extLst>
-          </p:cNvPr>
-          <p:cNvSpPr txBox="1"/>
-          <p:nvPr/>
-        </p:nvSpPr>
-        <p:spPr>
-          <a:xfrm>
-            <a:off x="7717407" y="5135890"/>
-            <a:ext cx="3569429" cy="738664"/>
-          </a:xfrm>
-          <a:prstGeom prst="rect">
-            <a:avLst/>
-          </a:prstGeom>
-          <a:noFill/>
-        </p:spPr>
-        <p:txBody>
-          <a:bodyPr wrap="square" rtlCol="0">
-            <a:spAutoFit/>
-          </a:bodyPr>
-          <a:lstStyle/>
-          <a:p>
-            <a:r>
-              <a:rPr lang="en-US" dirty="0"/>
-              <a:t>( I wanted to create the animation for this, but if this text is still here, then it has not been done yet.) </a:t>
-            </a:r>
-          </a:p>
-        </p:txBody>
-      </p:sp>
-      <p:sp>
-        <p:nvSpPr>
           <p:cNvPr id="8" name="Oval 7">
             <a:extLst>
               <a:ext uri="{FF2B5EF4-FFF2-40B4-BE49-F238E27FC236}">

</xml_diff>

<commit_message>
Incremental Build at 2026-10-17 16:41:10
</commit_message>
<xml_diff>
--- a/Lectures/Slides/L3.pptx
+++ b/Lectures/Slides/L3.pptx
@@ -31010,41 +31010,6 @@
       </p:pic>
       <p:sp>
         <p:nvSpPr>
-          <p:cNvPr id="7" name="TextBox 6">
-            <a:extLst>
-              <a:ext uri="{FF2B5EF4-FFF2-40B4-BE49-F238E27FC236}">
-                <a16:creationId xmlns:a16="http://schemas.microsoft.com/office/drawing/2014/main" id="{7E111A22-27B9-C2D3-DD45-1E7F5E82C23B}"/>
-              </a:ext>
-            </a:extLst>
-          </p:cNvPr>
-          <p:cNvSpPr txBox="1"/>
-          <p:nvPr/>
-        </p:nvSpPr>
-        <p:spPr>
-          <a:xfrm>
-            <a:off x="7717407" y="5135890"/>
-            <a:ext cx="3569429" cy="738664"/>
-          </a:xfrm>
-          <a:prstGeom prst="rect">
-            <a:avLst/>
-          </a:prstGeom>
-          <a:noFill/>
-        </p:spPr>
-        <p:txBody>
-          <a:bodyPr wrap="square" rtlCol="0">
-            <a:spAutoFit/>
-          </a:bodyPr>
-          <a:lstStyle/>
-          <a:p>
-            <a:r>
-              <a:rPr lang="en-US" dirty="0"/>
-              <a:t>( I wanted to create the animation for this, but if this text is still here, then it has not been done yet.) </a:t>
-            </a:r>
-          </a:p>
-        </p:txBody>
-      </p:sp>
-      <p:sp>
-        <p:nvSpPr>
           <p:cNvPr id="8" name="Oval 7">
             <a:extLst>
               <a:ext uri="{FF2B5EF4-FFF2-40B4-BE49-F238E27FC236}">

</xml_diff>